<commit_message>
Render the scoring equation as a slide-ready image
PowerPoint's equation editor behaves differently across versions, so the
equation ships as a transparent 300 dpi PNG instead. f and beta are
coloured to match the two mechanisms, and the activation threshold is
noted underneath rather than crowding the line itself.

make_equation.py regenerates it.

Co-Authored-By: Claude Opus 5 <noreply@anthropic.com>
</commit_message>
<xml_diff>
--- a/Wenjie_Jiang_Progress_Update_August2026.pptx
+++ b/Wenjie_Jiang_Progress_Update_August2026.pptx
@@ -266,10 +266,371 @@
       </p15:sldGuideLst>
     </p:ext>
     <p:ext uri="GoogleSlidesCustomDataVersion2">
-      <go:slidesCustomData xmlns="" xmlns:mc="http://schemas.openxmlformats.org/markup-compatibility/2006" xmlns:mv="urn:schemas-microsoft-com:mac:vml" xmlns:c="http://schemas.openxmlformats.org/drawingml/2006/chart" xmlns:dgm="http://schemas.openxmlformats.org/drawingml/2006/diagram" xmlns:o="urn:schemas-microsoft-com:office:office" xmlns:v="urn:schemas-microsoft-com:vml" xmlns:pvml="urn:schemas-microsoft-com:office:powerpoint" xmlns:com="http://schemas.openxmlformats.org/drawingml/2006/compatibility" xmlns:p14="http://schemas.microsoft.com/office/powerpoint/2010/main" xmlns:p15="http://schemas.microsoft.com/office/powerpoint/2012/main" xmlns:ahyp="http://schemas.microsoft.com/office/drawing/2018/hyperlinkcolor" xmlns:go="http://customooxmlschemas.google.com/" r:id="rId16" roundtripDataSignature="AMtx7mjhXBMYxZ4WvKmTGF4UVYOSy2IRhg=="/>
+      <go:slidesCustomData xmlns:go="http://customooxmlschemas.google.com/" xmlns:ahyp="http://schemas.microsoft.com/office/drawing/2018/hyperlinkcolor" xmlns:p15="http://schemas.microsoft.com/office/powerpoint/2012/main" xmlns:p14="http://schemas.microsoft.com/office/powerpoint/2010/main" xmlns:com="http://schemas.openxmlformats.org/drawingml/2006/compatibility" xmlns:pvml="urn:schemas-microsoft-com:office:powerpoint" xmlns:v="urn:schemas-microsoft-com:vml" xmlns:o="urn:schemas-microsoft-com:office:office" xmlns:dgm="http://schemas.openxmlformats.org/drawingml/2006/diagram" xmlns:c="http://schemas.openxmlformats.org/drawingml/2006/chart" xmlns:mv="urn:schemas-microsoft-com:mac:vml" xmlns:mc="http://schemas.openxmlformats.org/markup-compatibility/2006" xmlns="" r:id="rId16" roundtripDataSignature="AMtx7mjhXBMYxZ4WvKmTGF4UVYOSy2IRhg=="/>
     </p:ext>
   </p:extLst>
 </p:presentation>
+</file>
+
+<file path=ppt/revisionInfo.xml><?xml version="1.0" encoding="utf-8"?>
+<p1510:revInfo xmlns:a="http://schemas.openxmlformats.org/drawingml/2006/main" xmlns:r="http://schemas.openxmlformats.org/officeDocument/2006/relationships" xmlns:p1510="http://schemas.microsoft.com/office/powerpoint/2015/10/main">
+  <p1510:revLst>
+    <p1510:client id="{D363BF50-8B70-47AF-9712-C4A8D0ABD1C9}" v="4" dt="2026-10-28T08:57:31.144"/>
+  </p1510:revLst>
+</p1510:revInfo>
+</file>
+
+<file path=ppt/changesInfos/changesInfo1.xml><?xml version="1.0" encoding="utf-8"?>
+<pc:chgInfo xmlns:a="http://schemas.openxmlformats.org/drawingml/2006/main" xmlns:r="http://schemas.openxmlformats.org/officeDocument/2006/relationships" xmlns:ac="http://schemas.microsoft.com/office/drawing/2013/main/command" xmlns:pc="http://schemas.microsoft.com/office/powerpoint/2013/main/command">
+  <pc:docChgLst>
+    <pc:chgData name="wenjie jiang" userId="be32da44095649c9" providerId="LiveId" clId="{1C4DA2E3-8449-4E93-8194-94B48D8DB337}"/>
+    <pc:docChg chg="undo custSel modSld">
+      <pc:chgData name="wenjie jiang" userId="be32da44095649c9" providerId="LiveId" clId="{1C4DA2E3-8449-4E93-8194-94B48D8DB337}" dt="2026-10-28T09:08:31.452" v="164" actId="20577"/>
+      <pc:docMkLst>
+        <pc:docMk/>
+      </pc:docMkLst>
+      <pc:sldChg chg="modSp mod">
+        <pc:chgData name="wenjie jiang" userId="be32da44095649c9" providerId="LiveId" clId="{1C4DA2E3-8449-4E93-8194-94B48D8DB337}" dt="2026-10-28T08:21:49.009" v="8" actId="20577"/>
+        <pc:sldMkLst>
+          <pc:docMk/>
+          <pc:sldMk cId="0" sldId="256"/>
+        </pc:sldMkLst>
+        <pc:spChg chg="mod">
+          <ac:chgData name="wenjie jiang" userId="be32da44095649c9" providerId="LiveId" clId="{1C4DA2E3-8449-4E93-8194-94B48D8DB337}" dt="2026-10-28T08:21:49.009" v="8" actId="20577"/>
+          <ac:spMkLst>
+            <pc:docMk/>
+            <pc:sldMk cId="0" sldId="256"/>
+            <ac:spMk id="55" creationId="{00000000-0000-0000-0000-000000000000}"/>
+          </ac:spMkLst>
+        </pc:spChg>
+      </pc:sldChg>
+      <pc:sldChg chg="addSp delSp modSp mod">
+        <pc:chgData name="wenjie jiang" userId="be32da44095649c9" providerId="LiveId" clId="{1C4DA2E3-8449-4E93-8194-94B48D8DB337}" dt="2026-10-28T09:01:41.859" v="134" actId="1076"/>
+        <pc:sldMkLst>
+          <pc:docMk/>
+          <pc:sldMk cId="0" sldId="257"/>
+        </pc:sldMkLst>
+        <pc:spChg chg="add mod">
+          <ac:chgData name="wenjie jiang" userId="be32da44095649c9" providerId="LiveId" clId="{1C4DA2E3-8449-4E93-8194-94B48D8DB337}" dt="2026-10-28T08:50:42.620" v="52" actId="1076"/>
+          <ac:spMkLst>
+            <pc:docMk/>
+            <pc:sldMk cId="0" sldId="257"/>
+            <ac:spMk id="6" creationId="{C31934A6-045B-1C99-9350-2932BA1EA301}"/>
+          </ac:spMkLst>
+        </pc:spChg>
+        <pc:spChg chg="add del">
+          <ac:chgData name="wenjie jiang" userId="be32da44095649c9" providerId="LiveId" clId="{1C4DA2E3-8449-4E93-8194-94B48D8DB337}" dt="2026-10-28T08:49:30.089" v="51" actId="22"/>
+          <ac:spMkLst>
+            <pc:docMk/>
+            <pc:sldMk cId="0" sldId="257"/>
+            <ac:spMk id="8" creationId="{6F6D2BE8-FFA0-1B2D-C917-8DA1E7A6BEC2}"/>
+          </ac:spMkLst>
+        </pc:spChg>
+        <pc:spChg chg="mod">
+          <ac:chgData name="wenjie jiang" userId="be32da44095649c9" providerId="LiveId" clId="{1C4DA2E3-8449-4E93-8194-94B48D8DB337}" dt="2026-10-28T08:46:24.460" v="32" actId="20577"/>
+          <ac:spMkLst>
+            <pc:docMk/>
+            <pc:sldMk cId="0" sldId="257"/>
+            <ac:spMk id="60" creationId="{00000000-0000-0000-0000-000000000000}"/>
+          </ac:spMkLst>
+        </pc:spChg>
+        <pc:spChg chg="del mod">
+          <ac:chgData name="wenjie jiang" userId="be32da44095649c9" providerId="LiveId" clId="{1C4DA2E3-8449-4E93-8194-94B48D8DB337}" dt="2026-10-28T09:00:32.196" v="120" actId="21"/>
+          <ac:spMkLst>
+            <pc:docMk/>
+            <pc:sldMk cId="0" sldId="257"/>
+            <ac:spMk id="61" creationId="{00000000-0000-0000-0000-000000000000}"/>
+          </ac:spMkLst>
+        </pc:spChg>
+        <pc:spChg chg="del mod">
+          <ac:chgData name="wenjie jiang" userId="be32da44095649c9" providerId="LiveId" clId="{1C4DA2E3-8449-4E93-8194-94B48D8DB337}" dt="2026-10-28T08:46:46.751" v="39" actId="21"/>
+          <ac:spMkLst>
+            <pc:docMk/>
+            <pc:sldMk cId="0" sldId="257"/>
+            <ac:spMk id="63" creationId="{00000000-0000-0000-0000-000000000000}"/>
+          </ac:spMkLst>
+        </pc:spChg>
+        <pc:spChg chg="del">
+          <ac:chgData name="wenjie jiang" userId="be32da44095649c9" providerId="LiveId" clId="{1C4DA2E3-8449-4E93-8194-94B48D8DB337}" dt="2026-10-28T08:46:37.644" v="34" actId="478"/>
+          <ac:spMkLst>
+            <pc:docMk/>
+            <pc:sldMk cId="0" sldId="257"/>
+            <ac:spMk id="64" creationId="{00000000-0000-0000-0000-000000000000}"/>
+          </ac:spMkLst>
+        </pc:spChg>
+        <pc:spChg chg="mod">
+          <ac:chgData name="wenjie jiang" userId="be32da44095649c9" providerId="LiveId" clId="{1C4DA2E3-8449-4E93-8194-94B48D8DB337}" dt="2026-10-28T08:46:39.491" v="35" actId="20577"/>
+          <ac:spMkLst>
+            <pc:docMk/>
+            <pc:sldMk cId="0" sldId="257"/>
+            <ac:spMk id="65" creationId="{00000000-0000-0000-0000-000000000000}"/>
+          </ac:spMkLst>
+        </pc:spChg>
+        <pc:spChg chg="del mod">
+          <ac:chgData name="wenjie jiang" userId="be32da44095649c9" providerId="LiveId" clId="{1C4DA2E3-8449-4E93-8194-94B48D8DB337}" dt="2026-10-28T08:46:48.420" v="40" actId="21"/>
+          <ac:spMkLst>
+            <pc:docMk/>
+            <pc:sldMk cId="0" sldId="257"/>
+            <ac:spMk id="66" creationId="{00000000-0000-0000-0000-000000000000}"/>
+          </ac:spMkLst>
+        </pc:spChg>
+        <pc:picChg chg="del">
+          <ac:chgData name="wenjie jiang" userId="be32da44095649c9" providerId="LiveId" clId="{1C4DA2E3-8449-4E93-8194-94B48D8DB337}" dt="2026-10-28T08:46:51.819" v="41" actId="21"/>
+          <ac:picMkLst>
+            <pc:docMk/>
+            <pc:sldMk cId="0" sldId="257"/>
+            <ac:picMk id="3" creationId="{9D42DB37-BBCB-111C-32CE-69D61A5FC37A}"/>
+          </ac:picMkLst>
+        </pc:picChg>
+        <pc:picChg chg="add mod">
+          <ac:chgData name="wenjie jiang" userId="be32da44095649c9" providerId="LiveId" clId="{1C4DA2E3-8449-4E93-8194-94B48D8DB337}" dt="2026-10-28T09:01:41.859" v="134" actId="1076"/>
+          <ac:picMkLst>
+            <pc:docMk/>
+            <pc:sldMk cId="0" sldId="257"/>
+            <ac:picMk id="4" creationId="{2906C371-C0AB-0D5C-19BA-520C96488621}"/>
+          </ac:picMkLst>
+        </pc:picChg>
+      </pc:sldChg>
+      <pc:sldChg chg="addSp delSp modSp mod">
+        <pc:chgData name="wenjie jiang" userId="be32da44095649c9" providerId="LiveId" clId="{1C4DA2E3-8449-4E93-8194-94B48D8DB337}" dt="2026-10-28T09:08:31.452" v="164" actId="20577"/>
+        <pc:sldMkLst>
+          <pc:docMk/>
+          <pc:sldMk cId="0" sldId="258"/>
+        </pc:sldMkLst>
+        <pc:spChg chg="add del mod">
+          <ac:chgData name="wenjie jiang" userId="be32da44095649c9" providerId="LiveId" clId="{1C4DA2E3-8449-4E93-8194-94B48D8DB337}" dt="2026-10-28T08:56:07.923" v="62" actId="21"/>
+          <ac:spMkLst>
+            <pc:docMk/>
+            <pc:sldMk cId="0" sldId="258"/>
+            <ac:spMk id="3" creationId="{8C656B36-3195-E739-F955-2BD110476721}"/>
+          </ac:spMkLst>
+        </pc:spChg>
+        <pc:spChg chg="mod">
+          <ac:chgData name="wenjie jiang" userId="be32da44095649c9" providerId="LiveId" clId="{1C4DA2E3-8449-4E93-8194-94B48D8DB337}" dt="2026-10-28T09:08:31.452" v="164" actId="20577"/>
+          <ac:spMkLst>
+            <pc:docMk/>
+            <pc:sldMk cId="0" sldId="258"/>
+            <ac:spMk id="72" creationId="{00000000-0000-0000-0000-000000000000}"/>
+          </ac:spMkLst>
+        </pc:spChg>
+        <pc:spChg chg="del">
+          <ac:chgData name="wenjie jiang" userId="be32da44095649c9" providerId="LiveId" clId="{1C4DA2E3-8449-4E93-8194-94B48D8DB337}" dt="2026-10-28T08:56:01.831" v="60" actId="21"/>
+          <ac:spMkLst>
+            <pc:docMk/>
+            <pc:sldMk cId="0" sldId="258"/>
+            <ac:spMk id="73" creationId="{00000000-0000-0000-0000-000000000000}"/>
+          </ac:spMkLst>
+        </pc:spChg>
+        <pc:spChg chg="del">
+          <ac:chgData name="wenjie jiang" userId="be32da44095649c9" providerId="LiveId" clId="{1C4DA2E3-8449-4E93-8194-94B48D8DB337}" dt="2026-10-28T08:55:58.660" v="59" actId="21"/>
+          <ac:spMkLst>
+            <pc:docMk/>
+            <pc:sldMk cId="0" sldId="258"/>
+            <ac:spMk id="74" creationId="{00000000-0000-0000-0000-000000000000}"/>
+          </ac:spMkLst>
+        </pc:spChg>
+        <pc:spChg chg="del">
+          <ac:chgData name="wenjie jiang" userId="be32da44095649c9" providerId="LiveId" clId="{1C4DA2E3-8449-4E93-8194-94B48D8DB337}" dt="2026-10-28T08:56:13.284" v="64" actId="21"/>
+          <ac:spMkLst>
+            <pc:docMk/>
+            <pc:sldMk cId="0" sldId="258"/>
+            <ac:spMk id="75" creationId="{00000000-0000-0000-0000-000000000000}"/>
+          </ac:spMkLst>
+        </pc:spChg>
+        <pc:spChg chg="del">
+          <ac:chgData name="wenjie jiang" userId="be32da44095649c9" providerId="LiveId" clId="{1C4DA2E3-8449-4E93-8194-94B48D8DB337}" dt="2026-10-28T08:56:11.163" v="63" actId="21"/>
+          <ac:spMkLst>
+            <pc:docMk/>
+            <pc:sldMk cId="0" sldId="258"/>
+            <ac:spMk id="76" creationId="{00000000-0000-0000-0000-000000000000}"/>
+          </ac:spMkLst>
+        </pc:spChg>
+        <pc:picChg chg="add mod">
+          <ac:chgData name="wenjie jiang" userId="be32da44095649c9" providerId="LiveId" clId="{1C4DA2E3-8449-4E93-8194-94B48D8DB337}" dt="2026-10-28T09:01:47.371" v="135" actId="1076"/>
+          <ac:picMkLst>
+            <pc:docMk/>
+            <pc:sldMk cId="0" sldId="258"/>
+            <ac:picMk id="5" creationId="{AE677EC3-9EA5-8532-9DE6-5131CB742C62}"/>
+          </ac:picMkLst>
+        </pc:picChg>
+        <pc:picChg chg="del">
+          <ac:chgData name="wenjie jiang" userId="be32da44095649c9" providerId="LiveId" clId="{1C4DA2E3-8449-4E93-8194-94B48D8DB337}" dt="2026-10-28T08:56:15.371" v="65" actId="21"/>
+          <ac:picMkLst>
+            <pc:docMk/>
+            <pc:sldMk cId="0" sldId="258"/>
+            <ac:picMk id="8" creationId="{A8576A93-F256-EC44-FDF2-8A4A56103F43}"/>
+          </ac:picMkLst>
+        </pc:picChg>
+        <pc:picChg chg="del">
+          <ac:chgData name="wenjie jiang" userId="be32da44095649c9" providerId="LiveId" clId="{1C4DA2E3-8449-4E93-8194-94B48D8DB337}" dt="2026-10-28T08:56:16.298" v="66" actId="21"/>
+          <ac:picMkLst>
+            <pc:docMk/>
+            <pc:sldMk cId="0" sldId="258"/>
+            <ac:picMk id="10" creationId="{917F7C63-9E97-C60A-0E29-C683A32ED6B4}"/>
+          </ac:picMkLst>
+        </pc:picChg>
+        <pc:picChg chg="del">
+          <ac:chgData name="wenjie jiang" userId="be32da44095649c9" providerId="LiveId" clId="{1C4DA2E3-8449-4E93-8194-94B48D8DB337}" dt="2026-10-28T08:56:17.530" v="67" actId="21"/>
+          <ac:picMkLst>
+            <pc:docMk/>
+            <pc:sldMk cId="0" sldId="258"/>
+            <ac:picMk id="12" creationId="{D5EEA023-DBCC-DA23-03E1-A925B6DA4A70}"/>
+          </ac:picMkLst>
+        </pc:picChg>
+      </pc:sldChg>
+      <pc:sldChg chg="addSp delSp modSp mod">
+        <pc:chgData name="wenjie jiang" userId="be32da44095649c9" providerId="LiveId" clId="{1C4DA2E3-8449-4E93-8194-94B48D8DB337}" dt="2026-10-28T09:02:16.261" v="137" actId="1076"/>
+        <pc:sldMkLst>
+          <pc:docMk/>
+          <pc:sldMk cId="0" sldId="259"/>
+        </pc:sldMkLst>
+        <pc:spChg chg="add del mod">
+          <ac:chgData name="wenjie jiang" userId="be32da44095649c9" providerId="LiveId" clId="{1C4DA2E3-8449-4E93-8194-94B48D8DB337}" dt="2026-10-28T09:00:03.851" v="108" actId="21"/>
+          <ac:spMkLst>
+            <pc:docMk/>
+            <pc:sldMk cId="0" sldId="259"/>
+            <ac:spMk id="5" creationId="{1D887F8A-B5B8-D319-E844-FE4B02F29F6D}"/>
+          </ac:spMkLst>
+        </pc:spChg>
+        <pc:spChg chg="mod">
+          <ac:chgData name="wenjie jiang" userId="be32da44095649c9" providerId="LiveId" clId="{1C4DA2E3-8449-4E93-8194-94B48D8DB337}" dt="2026-10-28T08:59:58.785" v="106" actId="20577"/>
+          <ac:spMkLst>
+            <pc:docMk/>
+            <pc:sldMk cId="0" sldId="259"/>
+            <ac:spMk id="85" creationId="{00000000-0000-0000-0000-000000000000}"/>
+          </ac:spMkLst>
+        </pc:spChg>
+        <pc:spChg chg="del">
+          <ac:chgData name="wenjie jiang" userId="be32da44095649c9" providerId="LiveId" clId="{1C4DA2E3-8449-4E93-8194-94B48D8DB337}" dt="2026-10-28T09:00:02.182" v="107" actId="21"/>
+          <ac:spMkLst>
+            <pc:docMk/>
+            <pc:sldMk cId="0" sldId="259"/>
+            <ac:spMk id="86" creationId="{00000000-0000-0000-0000-000000000000}"/>
+          </ac:spMkLst>
+        </pc:spChg>
+        <pc:spChg chg="del">
+          <ac:chgData name="wenjie jiang" userId="be32da44095649c9" providerId="LiveId" clId="{1C4DA2E3-8449-4E93-8194-94B48D8DB337}" dt="2026-10-28T09:00:15.178" v="112" actId="21"/>
+          <ac:spMkLst>
+            <pc:docMk/>
+            <pc:sldMk cId="0" sldId="259"/>
+            <ac:spMk id="88" creationId="{00000000-0000-0000-0000-000000000000}"/>
+          </ac:spMkLst>
+        </pc:spChg>
+        <pc:spChg chg="del">
+          <ac:chgData name="wenjie jiang" userId="be32da44095649c9" providerId="LiveId" clId="{1C4DA2E3-8449-4E93-8194-94B48D8DB337}" dt="2026-10-28T09:00:16.894" v="113" actId="21"/>
+          <ac:spMkLst>
+            <pc:docMk/>
+            <pc:sldMk cId="0" sldId="259"/>
+            <ac:spMk id="89" creationId="{00000000-0000-0000-0000-000000000000}"/>
+          </ac:spMkLst>
+        </pc:spChg>
+        <pc:spChg chg="del">
+          <ac:chgData name="wenjie jiang" userId="be32da44095649c9" providerId="LiveId" clId="{1C4DA2E3-8449-4E93-8194-94B48D8DB337}" dt="2026-10-28T09:00:12.243" v="111" actId="21"/>
+          <ac:spMkLst>
+            <pc:docMk/>
+            <pc:sldMk cId="0" sldId="259"/>
+            <ac:spMk id="90" creationId="{00000000-0000-0000-0000-000000000000}"/>
+          </ac:spMkLst>
+        </pc:spChg>
+        <pc:spChg chg="del">
+          <ac:chgData name="wenjie jiang" userId="be32da44095649c9" providerId="LiveId" clId="{1C4DA2E3-8449-4E93-8194-94B48D8DB337}" dt="2026-10-28T09:00:10.205" v="110" actId="21"/>
+          <ac:spMkLst>
+            <pc:docMk/>
+            <pc:sldMk cId="0" sldId="259"/>
+            <ac:spMk id="91" creationId="{00000000-0000-0000-0000-000000000000}"/>
+          </ac:spMkLst>
+        </pc:spChg>
+        <pc:spChg chg="del">
+          <ac:chgData name="wenjie jiang" userId="be32da44095649c9" providerId="LiveId" clId="{1C4DA2E3-8449-4E93-8194-94B48D8DB337}" dt="2026-10-28T09:00:08.481" v="109" actId="21"/>
+          <ac:spMkLst>
+            <pc:docMk/>
+            <pc:sldMk cId="0" sldId="259"/>
+            <ac:spMk id="92" creationId="{00000000-0000-0000-0000-000000000000}"/>
+          </ac:spMkLst>
+        </pc:spChg>
+        <pc:spChg chg="del">
+          <ac:chgData name="wenjie jiang" userId="be32da44095649c9" providerId="LiveId" clId="{1C4DA2E3-8449-4E93-8194-94B48D8DB337}" dt="2026-10-28T09:00:25.039" v="117" actId="21"/>
+          <ac:spMkLst>
+            <pc:docMk/>
+            <pc:sldMk cId="0" sldId="259"/>
+            <ac:spMk id="93" creationId="{00000000-0000-0000-0000-000000000000}"/>
+          </ac:spMkLst>
+        </pc:spChg>
+        <pc:spChg chg="del">
+          <ac:chgData name="wenjie jiang" userId="be32da44095649c9" providerId="LiveId" clId="{1C4DA2E3-8449-4E93-8194-94B48D8DB337}" dt="2026-10-28T09:00:23.585" v="116" actId="21"/>
+          <ac:spMkLst>
+            <pc:docMk/>
+            <pc:sldMk cId="0" sldId="259"/>
+            <ac:spMk id="94" creationId="{00000000-0000-0000-0000-000000000000}"/>
+          </ac:spMkLst>
+        </pc:spChg>
+        <pc:picChg chg="add mod">
+          <ac:chgData name="wenjie jiang" userId="be32da44095649c9" providerId="LiveId" clId="{1C4DA2E3-8449-4E93-8194-94B48D8DB337}" dt="2026-10-28T09:02:16.261" v="137" actId="1076"/>
+          <ac:picMkLst>
+            <pc:docMk/>
+            <pc:sldMk cId="0" sldId="259"/>
+            <ac:picMk id="3" creationId="{06CB09F1-A38A-F12F-C2F9-2FEB5FD861EA}"/>
+          </ac:picMkLst>
+        </pc:picChg>
+      </pc:sldChg>
+      <pc:sldChg chg="addSp delSp modSp mod">
+        <pc:chgData name="wenjie jiang" userId="be32da44095649c9" providerId="LiveId" clId="{1C4DA2E3-8449-4E93-8194-94B48D8DB337}" dt="2026-10-28T09:02:56.135" v="159" actId="1076"/>
+        <pc:sldMkLst>
+          <pc:docMk/>
+          <pc:sldMk cId="0" sldId="260"/>
+        </pc:sldMkLst>
+        <pc:spChg chg="add del mod">
+          <ac:chgData name="wenjie jiang" userId="be32da44095649c9" providerId="LiveId" clId="{1C4DA2E3-8449-4E93-8194-94B48D8DB337}" dt="2026-10-28T09:02:37.063" v="156" actId="21"/>
+          <ac:spMkLst>
+            <pc:docMk/>
+            <pc:sldMk cId="0" sldId="260"/>
+            <ac:spMk id="3" creationId="{9E46DE4E-16E8-9B11-D863-677734B7AA1A}"/>
+          </ac:spMkLst>
+        </pc:spChg>
+        <pc:spChg chg="mod">
+          <ac:chgData name="wenjie jiang" userId="be32da44095649c9" providerId="LiveId" clId="{1C4DA2E3-8449-4E93-8194-94B48D8DB337}" dt="2026-10-28T09:02:29.920" v="154" actId="20577"/>
+          <ac:spMkLst>
+            <pc:docMk/>
+            <pc:sldMk cId="0" sldId="260"/>
+            <ac:spMk id="99" creationId="{00000000-0000-0000-0000-000000000000}"/>
+          </ac:spMkLst>
+        </pc:spChg>
+        <pc:spChg chg="del">
+          <ac:chgData name="wenjie jiang" userId="be32da44095649c9" providerId="LiveId" clId="{1C4DA2E3-8449-4E93-8194-94B48D8DB337}" dt="2026-10-28T09:02:35.403" v="155" actId="21"/>
+          <ac:spMkLst>
+            <pc:docMk/>
+            <pc:sldMk cId="0" sldId="260"/>
+            <ac:spMk id="100" creationId="{00000000-0000-0000-0000-000000000000}"/>
+          </ac:spMkLst>
+        </pc:spChg>
+        <pc:spChg chg="mod">
+          <ac:chgData name="wenjie jiang" userId="be32da44095649c9" providerId="LiveId" clId="{1C4DA2E3-8449-4E93-8194-94B48D8DB337}" dt="2026-10-28T09:02:56.135" v="159" actId="1076"/>
+          <ac:spMkLst>
+            <pc:docMk/>
+            <pc:sldMk cId="0" sldId="260"/>
+            <ac:spMk id="103" creationId="{00000000-0000-0000-0000-000000000000}"/>
+          </ac:spMkLst>
+        </pc:spChg>
+        <pc:spChg chg="del">
+          <ac:chgData name="wenjie jiang" userId="be32da44095649c9" providerId="LiveId" clId="{1C4DA2E3-8449-4E93-8194-94B48D8DB337}" dt="2026-10-28T09:02:52.100" v="158" actId="21"/>
+          <ac:spMkLst>
+            <pc:docMk/>
+            <pc:sldMk cId="0" sldId="260"/>
+            <ac:spMk id="104" creationId="{00000000-0000-0000-0000-000000000000}"/>
+          </ac:spMkLst>
+        </pc:spChg>
+        <pc:graphicFrameChg chg="del">
+          <ac:chgData name="wenjie jiang" userId="be32da44095649c9" providerId="LiveId" clId="{1C4DA2E3-8449-4E93-8194-94B48D8DB337}" dt="2026-10-28T09:02:38.918" v="157" actId="21"/>
+          <ac:graphicFrameMkLst>
+            <pc:docMk/>
+            <pc:sldMk cId="0" sldId="260"/>
+            <ac:graphicFrameMk id="102" creationId="{00000000-0000-0000-0000-000000000000}"/>
+          </ac:graphicFrameMkLst>
+        </pc:graphicFrameChg>
+      </pc:sldChg>
+    </pc:docChg>
+  </pc:docChgLst>
+</pc:chgInfo>
 </file>
 
 <file path=ppt/notesMasters/notesMaster1.xml><?xml version="1.0" encoding="utf-8"?>
@@ -10021,7 +10382,7 @@
                   <a:srgbClr val="555555"/>
                 </a:solidFill>
               </a:rPr>
-              <a:t>August</a:t>
+              <a:t>October</a:t>
             </a:r>
             <a:r>
               <a:rPr lang="en" b="0" i="0" u="none" strike="noStrike" cap="none" dirty="0">
@@ -10395,331 +10756,10 @@
               <a:buNone/>
             </a:pPr>
             <a:r>
-              <a:rPr lang="en" sz="2200" b="1" dirty="0"/>
-              <a:t>The Overall Project Scope and Objectives</a:t>
+              <a:rPr lang="en-US" sz="2200" b="1" dirty="0"/>
+              <a:t>Deciding on Their Own</a:t>
             </a:r>
             <a:endParaRPr sz="2200" b="1" dirty="0"/>
-          </a:p>
-        </p:txBody>
-      </p:sp>
-      <p:sp>
-        <p:nvSpPr>
-          <p:cNvPr id="61" name="Google Shape;61;p2"/>
-          <p:cNvSpPr txBox="1">
-            <a:spLocks noGrp="1"/>
-          </p:cNvSpPr>
-          <p:nvPr>
-            <p:ph type="body" idx="1"/>
-          </p:nvPr>
-        </p:nvSpPr>
-        <p:spPr>
-          <a:xfrm>
-            <a:off x="320040" y="1166258"/>
-            <a:ext cx="5524500" cy="1079400"/>
-          </a:xfrm>
-          <a:prstGeom prst="rect">
-            <a:avLst/>
-          </a:prstGeom>
-          <a:noFill/>
-          <a:ln>
-            <a:noFill/>
-          </a:ln>
-        </p:spPr>
-        <p:txBody>
-          <a:bodyPr spcFirstLastPara="1" wrap="square" lIns="91425" tIns="91425" rIns="91425" bIns="91425" anchor="t" anchorCtr="0">
-            <a:noAutofit/>
-          </a:bodyPr>
-          <a:lstStyle/>
-          <a:p>
-            <a:pPr marL="457200" lvl="0" indent="-317500" algn="l" rtl="0">
-              <a:lnSpc>
-                <a:spcPct val="150000"/>
-              </a:lnSpc>
-              <a:spcBef>
-                <a:spcPts val="1200"/>
-              </a:spcBef>
-              <a:spcAft>
-                <a:spcPts val="0"/>
-              </a:spcAft>
-              <a:buClr>
-                <a:schemeClr val="dk1"/>
-              </a:buClr>
-              <a:buSzPts val="1400"/>
-              <a:buChar char="●"/>
-            </a:pPr>
-            <a:r>
-              <a:rPr lang="en" sz="1400" dirty="0">
-                <a:solidFill>
-                  <a:schemeClr val="dk1"/>
-                </a:solidFill>
-              </a:rPr>
-              <a:t>2D Unity simulation, single-room greybox environment</a:t>
-            </a:r>
-            <a:endParaRPr sz="1400" dirty="0">
-              <a:solidFill>
-                <a:schemeClr val="dk1"/>
-              </a:solidFill>
-            </a:endParaRPr>
-          </a:p>
-          <a:p>
-            <a:pPr marL="457200" lvl="0" indent="-317500" algn="l" rtl="0">
-              <a:lnSpc>
-                <a:spcPct val="150000"/>
-              </a:lnSpc>
-              <a:spcBef>
-                <a:spcPts val="0"/>
-              </a:spcBef>
-              <a:spcAft>
-                <a:spcPts val="0"/>
-              </a:spcAft>
-              <a:buClr>
-                <a:schemeClr val="dk1"/>
-              </a:buClr>
-              <a:buSzPts val="1400"/>
-              <a:buChar char="●"/>
-            </a:pPr>
-            <a:r>
-              <a:rPr lang="en" sz="1400" dirty="0">
-                <a:solidFill>
-                  <a:schemeClr val="dk1"/>
-                </a:solidFill>
-              </a:rPr>
-              <a:t>Two agents sharing identical bodies, differing in decision brain</a:t>
-            </a:r>
-            <a:endParaRPr sz="1400" dirty="0">
-              <a:solidFill>
-                <a:schemeClr val="dk1"/>
-              </a:solidFill>
-            </a:endParaRPr>
-          </a:p>
-          <a:p>
-            <a:pPr marL="457200" lvl="0" indent="-317500" algn="l" rtl="0">
-              <a:lnSpc>
-                <a:spcPct val="150000"/>
-              </a:lnSpc>
-              <a:spcBef>
-                <a:spcPts val="0"/>
-              </a:spcBef>
-              <a:spcAft>
-                <a:spcPts val="0"/>
-              </a:spcAft>
-              <a:buClr>
-                <a:schemeClr val="dk1"/>
-              </a:buClr>
-              <a:buSzPts val="1400"/>
-              <a:buChar char="●"/>
-            </a:pPr>
-            <a:r>
-              <a:rPr lang="en" sz="1400" dirty="0">
-                <a:solidFill>
-                  <a:schemeClr val="dk1"/>
-                </a:solidFill>
-              </a:rPr>
-              <a:t>Shared needs: hunger and energy</a:t>
-            </a:r>
-            <a:endParaRPr sz="1400" dirty="0">
-              <a:solidFill>
-                <a:schemeClr val="dk1"/>
-              </a:solidFill>
-            </a:endParaRPr>
-          </a:p>
-          <a:p>
-            <a:pPr marL="0" lvl="0" indent="0" algn="l" rtl="0">
-              <a:lnSpc>
-                <a:spcPct val="150000"/>
-              </a:lnSpc>
-              <a:spcBef>
-                <a:spcPts val="1200"/>
-              </a:spcBef>
-              <a:spcAft>
-                <a:spcPts val="0"/>
-              </a:spcAft>
-              <a:buClr>
-                <a:schemeClr val="dk1"/>
-              </a:buClr>
-              <a:buSzPts val="688"/>
-              <a:buFont typeface="Arial"/>
-              <a:buNone/>
-            </a:pPr>
-            <a:endParaRPr sz="1125" dirty="0"/>
-          </a:p>
-        </p:txBody>
-      </p:sp>
-      <p:sp>
-        <p:nvSpPr>
-          <p:cNvPr id="63" name="Google Shape;63;p2"/>
-          <p:cNvSpPr txBox="1"/>
-          <p:nvPr/>
-        </p:nvSpPr>
-        <p:spPr>
-          <a:xfrm>
-            <a:off x="320040" y="3633363"/>
-            <a:ext cx="7620000" cy="794100"/>
-          </a:xfrm>
-          <a:prstGeom prst="rect">
-            <a:avLst/>
-          </a:prstGeom>
-          <a:noFill/>
-          <a:ln>
-            <a:noFill/>
-          </a:ln>
-        </p:spPr>
-        <p:txBody>
-          <a:bodyPr spcFirstLastPara="1" wrap="square" lIns="91425" tIns="91425" rIns="91425" bIns="91425" anchor="t" anchorCtr="0">
-            <a:noAutofit/>
-          </a:bodyPr>
-          <a:lstStyle/>
-          <a:p>
-            <a:pPr marL="457200" lvl="0" indent="-317500" algn="l" rtl="0">
-              <a:lnSpc>
-                <a:spcPct val="150000"/>
-              </a:lnSpc>
-              <a:spcBef>
-                <a:spcPts val="0"/>
-              </a:spcBef>
-              <a:spcAft>
-                <a:spcPts val="0"/>
-              </a:spcAft>
-              <a:buClr>
-                <a:schemeClr val="dk1"/>
-              </a:buClr>
-              <a:buSzPts val="1400"/>
-              <a:buAutoNum type="arabicPeriod"/>
-            </a:pPr>
-            <a:r>
-              <a:rPr lang="en" b="1" dirty="0">
-                <a:solidFill>
-                  <a:schemeClr val="dk1"/>
-                </a:solidFill>
-              </a:rPr>
-              <a:t>Stability </a:t>
-            </a:r>
-            <a:r>
-              <a:rPr lang="en" dirty="0">
-                <a:solidFill>
-                  <a:schemeClr val="dk1"/>
-                </a:solidFill>
-              </a:rPr>
-              <a:t>— consistent behavior, preventing behavioral oscillation between actions</a:t>
-            </a:r>
-            <a:endParaRPr dirty="0">
-              <a:solidFill>
-                <a:schemeClr val="dk1"/>
-              </a:solidFill>
-            </a:endParaRPr>
-          </a:p>
-          <a:p>
-            <a:pPr marL="457200" lvl="0" indent="-317500" algn="l" rtl="0">
-              <a:lnSpc>
-                <a:spcPct val="150000"/>
-              </a:lnSpc>
-              <a:spcBef>
-                <a:spcPts val="0"/>
-              </a:spcBef>
-              <a:spcAft>
-                <a:spcPts val="0"/>
-              </a:spcAft>
-              <a:buClr>
-                <a:schemeClr val="dk1"/>
-              </a:buClr>
-              <a:buSzPts val="1400"/>
-              <a:buAutoNum type="arabicPeriod"/>
-            </a:pPr>
-            <a:r>
-              <a:rPr lang="en" b="1" dirty="0">
-                <a:solidFill>
-                  <a:schemeClr val="dk1"/>
-                </a:solidFill>
-              </a:rPr>
-              <a:t>Adaptability </a:t>
-            </a:r>
-            <a:r>
-              <a:rPr lang="en" dirty="0">
-                <a:solidFill>
-                  <a:schemeClr val="dk1"/>
-                </a:solidFill>
-              </a:rPr>
-              <a:t>— dynamically adjusts behavior when resources are removed</a:t>
-            </a:r>
-            <a:endParaRPr dirty="0">
-              <a:solidFill>
-                <a:schemeClr val="dk1"/>
-              </a:solidFill>
-            </a:endParaRPr>
-          </a:p>
-          <a:p>
-            <a:pPr marL="0" lvl="0" indent="0" algn="l" rtl="0">
-              <a:spcBef>
-                <a:spcPts val="0"/>
-              </a:spcBef>
-              <a:spcAft>
-                <a:spcPts val="0"/>
-              </a:spcAft>
-              <a:buNone/>
-            </a:pPr>
-            <a:endParaRPr sz="1800" dirty="0">
-              <a:solidFill>
-                <a:schemeClr val="dk2"/>
-              </a:solidFill>
-            </a:endParaRPr>
-          </a:p>
-        </p:txBody>
-      </p:sp>
-      <p:sp>
-        <p:nvSpPr>
-          <p:cNvPr id="64" name="Google Shape;64;p2"/>
-          <p:cNvSpPr txBox="1"/>
-          <p:nvPr/>
-        </p:nvSpPr>
-        <p:spPr>
-          <a:xfrm>
-            <a:off x="548639" y="914400"/>
-            <a:ext cx="1058400" cy="405372"/>
-          </a:xfrm>
-          <a:prstGeom prst="rect">
-            <a:avLst/>
-          </a:prstGeom>
-          <a:noFill/>
-          <a:ln>
-            <a:noFill/>
-          </a:ln>
-        </p:spPr>
-        <p:txBody>
-          <a:bodyPr spcFirstLastPara="1" wrap="square" lIns="91425" tIns="91425" rIns="91425" bIns="91425" anchor="t" anchorCtr="0">
-            <a:noAutofit/>
-          </a:bodyPr>
-          <a:lstStyle/>
-          <a:p>
-            <a:pPr marL="0" lvl="0" indent="0" algn="l" rtl="0">
-              <a:lnSpc>
-                <a:spcPct val="150000"/>
-              </a:lnSpc>
-              <a:spcBef>
-                <a:spcPts val="0"/>
-              </a:spcBef>
-              <a:spcAft>
-                <a:spcPts val="0"/>
-              </a:spcAft>
-              <a:buClr>
-                <a:schemeClr val="dk1"/>
-              </a:buClr>
-              <a:buSzPts val="688"/>
-              <a:buFont typeface="Arial"/>
-              <a:buNone/>
-            </a:pPr>
-            <a:r>
-              <a:rPr lang="en" sz="1800" b="1" dirty="0">
-                <a:solidFill>
-                  <a:schemeClr val="dk1"/>
-                </a:solidFill>
-              </a:rPr>
-              <a:t>Scope</a:t>
-            </a:r>
-            <a:endParaRPr sz="1800" dirty="0">
-              <a:solidFill>
-                <a:schemeClr val="dk2"/>
-              </a:solidFill>
-            </a:endParaRPr>
           </a:p>
         </p:txBody>
       </p:sp>
@@ -10765,73 +10805,7 @@
               <a:buFont typeface="Arial"/>
               <a:buNone/>
             </a:pPr>
-            <a:r>
-              <a:rPr lang="en" sz="1800" b="1" dirty="0">
-                <a:solidFill>
-                  <a:schemeClr val="dk1"/>
-                </a:solidFill>
-              </a:rPr>
-              <a:t>Objectives</a:t>
-            </a:r>
             <a:endParaRPr sz="1800" dirty="0">
-              <a:solidFill>
-                <a:schemeClr val="dk2"/>
-              </a:solidFill>
-            </a:endParaRPr>
-          </a:p>
-        </p:txBody>
-      </p:sp>
-      <p:sp>
-        <p:nvSpPr>
-          <p:cNvPr id="66" name="Google Shape;66;p2"/>
-          <p:cNvSpPr txBox="1"/>
-          <p:nvPr/>
-        </p:nvSpPr>
-        <p:spPr>
-          <a:xfrm>
-            <a:off x="62940" y="2879078"/>
-            <a:ext cx="8134200" cy="729900"/>
-          </a:xfrm>
-          <a:prstGeom prst="rect">
-            <a:avLst/>
-          </a:prstGeom>
-          <a:noFill/>
-          <a:ln>
-            <a:noFill/>
-          </a:ln>
-        </p:spPr>
-        <p:txBody>
-          <a:bodyPr spcFirstLastPara="1" wrap="square" lIns="91425" tIns="91425" rIns="91425" bIns="91425" anchor="t" anchorCtr="0">
-            <a:noAutofit/>
-          </a:bodyPr>
-          <a:lstStyle/>
-          <a:p>
-            <a:pPr marL="457200" lvl="0" indent="0" algn="l" rtl="0">
-              <a:lnSpc>
-                <a:spcPct val="150000"/>
-              </a:lnSpc>
-              <a:spcBef>
-                <a:spcPts val="0"/>
-              </a:spcBef>
-              <a:spcAft>
-                <a:spcPts val="0"/>
-              </a:spcAft>
-              <a:buClr>
-                <a:schemeClr val="dk1"/>
-              </a:buClr>
-              <a:buSzPts val="1100"/>
-              <a:buFont typeface="Arial"/>
-              <a:buNone/>
-            </a:pPr>
-            <a:r>
-              <a:rPr lang="en" i="1" dirty="0">
-                <a:solidFill>
-                  <a:schemeClr val="dk1"/>
-                </a:solidFill>
-              </a:rPr>
-              <a:t>We compare a baseline threshold agent (rigid) against a utility-scored agent (fluid) across stability and adaptability metrics</a:t>
-            </a:r>
-            <a:endParaRPr sz="1800" i="1" dirty="0">
               <a:solidFill>
                 <a:schemeClr val="dk2"/>
               </a:solidFill>
@@ -10888,10 +10862,10 @@
       </p:sp>
       <p:pic>
         <p:nvPicPr>
-          <p:cNvPr id="3" name="Picture 2">
+          <p:cNvPr id="4" name="Picture 3">
             <a:extLst>
               <a:ext uri="{FF2B5EF4-FFF2-40B4-BE49-F238E27FC236}">
-                <a16:creationId xmlns:a16="http://schemas.microsoft.com/office/drawing/2014/main" id="{9D42DB37-BBCB-111C-32CE-69D61A5FC37A}"/>
+                <a16:creationId xmlns:a16="http://schemas.microsoft.com/office/drawing/2014/main" id="{2906C371-C0AB-0D5C-19BA-520C96488621}"/>
               </a:ext>
             </a:extLst>
           </p:cNvPr>
@@ -10908,14 +10882,70 @@
         </p:blipFill>
         <p:spPr>
           <a:xfrm>
-            <a:off x="6367876" y="1117086"/>
-            <a:ext cx="1259874" cy="1802566"/>
+            <a:off x="2743200" y="1371600"/>
+            <a:ext cx="3598560" cy="2704699"/>
           </a:xfrm>
           <a:prstGeom prst="rect">
             <a:avLst/>
           </a:prstGeom>
         </p:spPr>
       </p:pic>
+      <p:sp>
+        <p:nvSpPr>
+          <p:cNvPr id="6" name="Google Shape;103;p5">
+            <a:extLst>
+              <a:ext uri="{FF2B5EF4-FFF2-40B4-BE49-F238E27FC236}">
+                <a16:creationId xmlns:a16="http://schemas.microsoft.com/office/drawing/2014/main" id="{C31934A6-045B-1C99-9350-2932BA1EA301}"/>
+              </a:ext>
+            </a:extLst>
+          </p:cNvPr>
+          <p:cNvSpPr txBox="1"/>
+          <p:nvPr/>
+        </p:nvSpPr>
+        <p:spPr>
+          <a:xfrm>
+            <a:off x="7315200" y="4389120"/>
+            <a:ext cx="1517100" cy="393600"/>
+          </a:xfrm>
+          <a:prstGeom prst="rect">
+            <a:avLst/>
+          </a:prstGeom>
+          <a:noFill/>
+          <a:ln>
+            <a:noFill/>
+          </a:ln>
+        </p:spPr>
+        <p:txBody>
+          <a:bodyPr spcFirstLastPara="1" wrap="square" lIns="91425" tIns="91425" rIns="91425" bIns="91425" anchor="t" anchorCtr="0">
+            <a:noAutofit/>
+          </a:bodyPr>
+          <a:lstStyle/>
+          <a:p>
+            <a:pPr marL="0" lvl="0" indent="0" algn="l" rtl="0">
+              <a:spcBef>
+                <a:spcPts val="0"/>
+              </a:spcBef>
+              <a:spcAft>
+                <a:spcPts val="0"/>
+              </a:spcAft>
+              <a:buNone/>
+            </a:pPr>
+            <a:r>
+              <a:rPr lang="en" sz="1100" dirty="0">
+                <a:solidFill>
+                  <a:schemeClr val="dk2"/>
+                </a:solidFill>
+              </a:rPr>
+              <a:t>(Mark, 2009)</a:t>
+            </a:r>
+            <a:endParaRPr sz="1100" dirty="0">
+              <a:solidFill>
+                <a:schemeClr val="dk2"/>
+              </a:solidFill>
+            </a:endParaRPr>
+          </a:p>
+        </p:txBody>
+      </p:sp>
     </p:spTree>
   </p:cSld>
   <p:clrMapOvr>
@@ -10984,445 +11014,10 @@
               <a:buNone/>
             </a:pPr>
             <a:r>
-              <a:rPr lang="en" sz="2200" b="1"/>
-              <a:t>Proposed Methodology and Technical Approach</a:t>
+              <a:rPr lang="en" sz="2200" b="1" dirty="0"/>
+              <a:t>The Setup</a:t>
             </a:r>
-            <a:endParaRPr sz="2200" b="1"/>
-          </a:p>
-        </p:txBody>
-      </p:sp>
-      <p:sp>
-        <p:nvSpPr>
-          <p:cNvPr id="73" name="Google Shape;73;p3"/>
-          <p:cNvSpPr txBox="1">
-            <a:spLocks noGrp="1"/>
-          </p:cNvSpPr>
-          <p:nvPr>
-            <p:ph type="body" idx="1"/>
-          </p:nvPr>
-        </p:nvSpPr>
-        <p:spPr>
-          <a:xfrm>
-            <a:off x="548640" y="914400"/>
-            <a:ext cx="2925900" cy="572700"/>
-          </a:xfrm>
-          <a:prstGeom prst="rect">
-            <a:avLst/>
-          </a:prstGeom>
-          <a:noFill/>
-          <a:ln>
-            <a:noFill/>
-          </a:ln>
-        </p:spPr>
-        <p:txBody>
-          <a:bodyPr spcFirstLastPara="1" wrap="square" lIns="91425" tIns="91425" rIns="91425" bIns="91425" anchor="t" anchorCtr="0">
-            <a:normAutofit fontScale="25000" lnSpcReduction="20000"/>
-          </a:bodyPr>
-          <a:lstStyle/>
-          <a:p>
-            <a:pPr marL="0" lvl="0" indent="0" algn="l" rtl="0">
-              <a:lnSpc>
-                <a:spcPct val="150000"/>
-              </a:lnSpc>
-              <a:spcBef>
-                <a:spcPts val="0"/>
-              </a:spcBef>
-              <a:spcAft>
-                <a:spcPts val="0"/>
-              </a:spcAft>
-              <a:buNone/>
-            </a:pPr>
-            <a:r>
-              <a:rPr lang="en" sz="7200" b="1" dirty="0">
-                <a:solidFill>
-                  <a:schemeClr val="dk1"/>
-                </a:solidFill>
-              </a:rPr>
-              <a:t>Experimental Method</a:t>
-            </a:r>
-            <a:endParaRPr sz="7200" dirty="0">
-              <a:solidFill>
-                <a:schemeClr val="dk1"/>
-              </a:solidFill>
-            </a:endParaRPr>
-          </a:p>
-          <a:p>
-            <a:pPr marL="0" lvl="0" indent="0" algn="l" rtl="0">
-              <a:lnSpc>
-                <a:spcPct val="150000"/>
-              </a:lnSpc>
-              <a:spcBef>
-                <a:spcPts val="0"/>
-              </a:spcBef>
-              <a:spcAft>
-                <a:spcPts val="0"/>
-              </a:spcAft>
-              <a:buNone/>
-            </a:pPr>
-            <a:endParaRPr sz="3600" dirty="0">
-              <a:solidFill>
-                <a:schemeClr val="dk1"/>
-              </a:solidFill>
-            </a:endParaRPr>
-          </a:p>
-          <a:p>
-            <a:pPr marL="0" lvl="0" indent="0" algn="l" rtl="0">
-              <a:lnSpc>
-                <a:spcPct val="150000"/>
-              </a:lnSpc>
-              <a:spcBef>
-                <a:spcPts val="0"/>
-              </a:spcBef>
-              <a:spcAft>
-                <a:spcPts val="0"/>
-              </a:spcAft>
-              <a:buNone/>
-            </a:pPr>
-            <a:endParaRPr sz="4300" dirty="0">
-              <a:solidFill>
-                <a:schemeClr val="dk1"/>
-              </a:solidFill>
-            </a:endParaRPr>
-          </a:p>
-        </p:txBody>
-      </p:sp>
-      <p:sp>
-        <p:nvSpPr>
-          <p:cNvPr id="74" name="Google Shape;74;p3"/>
-          <p:cNvSpPr txBox="1"/>
-          <p:nvPr/>
-        </p:nvSpPr>
-        <p:spPr>
-          <a:xfrm>
-            <a:off x="274320" y="1280160"/>
-            <a:ext cx="6328800" cy="1005300"/>
-          </a:xfrm>
-          <a:prstGeom prst="rect">
-            <a:avLst/>
-          </a:prstGeom>
-          <a:noFill/>
-          <a:ln>
-            <a:noFill/>
-          </a:ln>
-        </p:spPr>
-        <p:txBody>
-          <a:bodyPr spcFirstLastPara="1" wrap="square" lIns="91425" tIns="91425" rIns="91425" bIns="91425" anchor="t" anchorCtr="0">
-            <a:noAutofit/>
-          </a:bodyPr>
-          <a:lstStyle/>
-          <a:p>
-            <a:pPr marL="457200" lvl="0" indent="-317500" algn="l" rtl="0">
-              <a:lnSpc>
-                <a:spcPct val="150000"/>
-              </a:lnSpc>
-              <a:spcBef>
-                <a:spcPts val="0"/>
-              </a:spcBef>
-              <a:spcAft>
-                <a:spcPts val="0"/>
-              </a:spcAft>
-              <a:buClr>
-                <a:schemeClr val="dk1"/>
-              </a:buClr>
-              <a:buSzPts val="1400"/>
-              <a:buChar char="●"/>
-            </a:pPr>
-            <a:r>
-              <a:rPr lang="en" dirty="0">
-                <a:solidFill>
-                  <a:schemeClr val="dk1"/>
-                </a:solidFill>
-              </a:rPr>
-              <a:t>Same body, different brains — measured on stability and adaptability</a:t>
-            </a:r>
-            <a:endParaRPr dirty="0">
-              <a:solidFill>
-                <a:schemeClr val="dk1"/>
-              </a:solidFill>
-            </a:endParaRPr>
-          </a:p>
-          <a:p>
-            <a:pPr marL="457200" lvl="0" indent="-317500" algn="l" rtl="0">
-              <a:lnSpc>
-                <a:spcPct val="150000"/>
-              </a:lnSpc>
-              <a:spcBef>
-                <a:spcPts val="0"/>
-              </a:spcBef>
-              <a:spcAft>
-                <a:spcPts val="0"/>
-              </a:spcAft>
-              <a:buClr>
-                <a:schemeClr val="dk1"/>
-              </a:buClr>
-              <a:buSzPts val="1400"/>
-              <a:buChar char="●"/>
-            </a:pPr>
-            <a:r>
-              <a:rPr lang="en" b="1" dirty="0">
-                <a:solidFill>
-                  <a:schemeClr val="dk1"/>
-                </a:solidFill>
-              </a:rPr>
-              <a:t>Baseline </a:t>
-            </a:r>
-            <a:r>
-              <a:rPr lang="en" dirty="0">
-                <a:solidFill>
-                  <a:schemeClr val="dk1"/>
-                </a:solidFill>
-              </a:rPr>
-              <a:t>— priority-ordered threshold rules</a:t>
-            </a:r>
-            <a:endParaRPr dirty="0">
-              <a:solidFill>
-                <a:schemeClr val="dk1"/>
-              </a:solidFill>
-            </a:endParaRPr>
-          </a:p>
-          <a:p>
-            <a:pPr marL="457200" lvl="0" indent="-317500" algn="l" rtl="0">
-              <a:lnSpc>
-                <a:spcPct val="150000"/>
-              </a:lnSpc>
-              <a:spcBef>
-                <a:spcPts val="0"/>
-              </a:spcBef>
-              <a:spcAft>
-                <a:spcPts val="0"/>
-              </a:spcAft>
-              <a:buClr>
-                <a:schemeClr val="dk1"/>
-              </a:buClr>
-              <a:buSzPts val="1400"/>
-              <a:buChar char="●"/>
-            </a:pPr>
-            <a:r>
-              <a:rPr lang="en" b="1" dirty="0">
-                <a:solidFill>
-                  <a:schemeClr val="dk1"/>
-                </a:solidFill>
-              </a:rPr>
-              <a:t>Utility </a:t>
-            </a:r>
-            <a:r>
-              <a:rPr lang="en" dirty="0">
-                <a:solidFill>
-                  <a:schemeClr val="dk1"/>
-                </a:solidFill>
-              </a:rPr>
-              <a:t>— response curves + action inertia (highest-scoring action wins)</a:t>
-            </a:r>
-            <a:endParaRPr dirty="0">
-              <a:solidFill>
-                <a:schemeClr val="dk1"/>
-              </a:solidFill>
-            </a:endParaRPr>
-          </a:p>
-        </p:txBody>
-      </p:sp>
-      <p:sp>
-        <p:nvSpPr>
-          <p:cNvPr id="75" name="Google Shape;75;p3"/>
-          <p:cNvSpPr txBox="1"/>
-          <p:nvPr/>
-        </p:nvSpPr>
-        <p:spPr>
-          <a:xfrm>
-            <a:off x="274320" y="2761756"/>
-            <a:ext cx="5861447" cy="1953859"/>
-          </a:xfrm>
-          <a:prstGeom prst="rect">
-            <a:avLst/>
-          </a:prstGeom>
-          <a:noFill/>
-          <a:ln>
-            <a:noFill/>
-          </a:ln>
-        </p:spPr>
-        <p:txBody>
-          <a:bodyPr spcFirstLastPara="1" wrap="square" lIns="91425" tIns="91425" rIns="91425" bIns="91425" anchor="t" anchorCtr="0">
-            <a:noAutofit/>
-          </a:bodyPr>
-          <a:lstStyle/>
-          <a:p>
-            <a:pPr marL="457200" lvl="0" indent="-317500" algn="l" rtl="0">
-              <a:lnSpc>
-                <a:spcPct val="150000"/>
-              </a:lnSpc>
-              <a:spcBef>
-                <a:spcPts val="0"/>
-              </a:spcBef>
-              <a:spcAft>
-                <a:spcPts val="0"/>
-              </a:spcAft>
-              <a:buClr>
-                <a:schemeClr val="dk1"/>
-              </a:buClr>
-              <a:buSzPts val="1400"/>
-              <a:buChar char="●"/>
-            </a:pPr>
-            <a:r>
-              <a:rPr lang="en" dirty="0">
-                <a:solidFill>
-                  <a:schemeClr val="dk1"/>
-                </a:solidFill>
-              </a:rPr>
-              <a:t>Swappable brain component — same body, plug in Baseline or Utility</a:t>
-            </a:r>
-            <a:endParaRPr dirty="0">
-              <a:solidFill>
-                <a:schemeClr val="dk1"/>
-              </a:solidFill>
-            </a:endParaRPr>
-          </a:p>
-          <a:p>
-            <a:pPr marL="457200" lvl="0" indent="-317500" algn="l" rtl="0">
-              <a:lnSpc>
-                <a:spcPct val="150000"/>
-              </a:lnSpc>
-              <a:spcBef>
-                <a:spcPts val="0"/>
-              </a:spcBef>
-              <a:spcAft>
-                <a:spcPts val="0"/>
-              </a:spcAft>
-              <a:buClr>
-                <a:schemeClr val="dk1"/>
-              </a:buClr>
-              <a:buSzPts val="1400"/>
-              <a:buChar char="●"/>
-            </a:pPr>
-            <a:r>
-              <a:rPr lang="en" dirty="0">
-                <a:solidFill>
-                  <a:schemeClr val="dk1"/>
-                </a:solidFill>
-              </a:rPr>
-              <a:t>ScriptableObject data layer — Needs, Curves, Smart Objects</a:t>
-            </a:r>
-            <a:endParaRPr dirty="0">
-              <a:solidFill>
-                <a:schemeClr val="dk1"/>
-              </a:solidFill>
-            </a:endParaRPr>
-          </a:p>
-          <a:p>
-            <a:pPr marL="457200" lvl="0" indent="-317500" algn="l" rtl="0">
-              <a:lnSpc>
-                <a:spcPct val="150000"/>
-              </a:lnSpc>
-              <a:spcBef>
-                <a:spcPts val="0"/>
-              </a:spcBef>
-              <a:spcAft>
-                <a:spcPts val="0"/>
-              </a:spcAft>
-              <a:buClr>
-                <a:schemeClr val="dk1"/>
-              </a:buClr>
-              <a:buSzPts val="1400"/>
-              <a:buChar char="●"/>
-            </a:pPr>
-            <a:r>
-              <a:rPr lang="en" dirty="0">
-                <a:solidFill>
-                  <a:schemeClr val="dk1"/>
-                </a:solidFill>
-              </a:rPr>
-              <a:t>Pull-based perception — agent scans world each decision cycle</a:t>
-            </a:r>
-          </a:p>
-          <a:p>
-            <a:pPr marL="457200" lvl="0" indent="-317500">
-              <a:lnSpc>
-                <a:spcPct val="150000"/>
-              </a:lnSpc>
-              <a:buClr>
-                <a:schemeClr val="dk1"/>
-              </a:buClr>
-              <a:buSzPts val="1400"/>
-              <a:buChar char="●"/>
-            </a:pPr>
-            <a:r>
-              <a:rPr lang="en-US" dirty="0">
-                <a:solidFill>
-                  <a:schemeClr val="dk1"/>
-                </a:solidFill>
-              </a:rPr>
-              <a:t>Instrumentation layer — decisions and run configurations logged to CSV</a:t>
-            </a:r>
-            <a:endParaRPr dirty="0">
-              <a:solidFill>
-                <a:schemeClr val="dk1"/>
-              </a:solidFill>
-            </a:endParaRPr>
-          </a:p>
-        </p:txBody>
-      </p:sp>
-      <p:sp>
-        <p:nvSpPr>
-          <p:cNvPr id="76" name="Google Shape;76;p3"/>
-          <p:cNvSpPr txBox="1"/>
-          <p:nvPr/>
-        </p:nvSpPr>
-        <p:spPr>
-          <a:xfrm>
-            <a:off x="548640" y="2492772"/>
-            <a:ext cx="4508400" cy="478800"/>
-          </a:xfrm>
-          <a:prstGeom prst="rect">
-            <a:avLst/>
-          </a:prstGeom>
-          <a:noFill/>
-          <a:ln>
-            <a:noFill/>
-          </a:ln>
-        </p:spPr>
-        <p:txBody>
-          <a:bodyPr spcFirstLastPara="1" wrap="square" lIns="91425" tIns="91425" rIns="91425" bIns="91425" anchor="t" anchorCtr="0">
-            <a:noAutofit/>
-          </a:bodyPr>
-          <a:lstStyle/>
-          <a:p>
-            <a:pPr marL="0" lvl="0" indent="0" algn="l" rtl="0">
-              <a:spcBef>
-                <a:spcPts val="0"/>
-              </a:spcBef>
-              <a:spcAft>
-                <a:spcPts val="0"/>
-              </a:spcAft>
-              <a:buNone/>
-            </a:pPr>
-            <a:r>
-              <a:rPr lang="en" sz="1800" b="1" dirty="0">
-                <a:solidFill>
-                  <a:schemeClr val="dk1"/>
-                </a:solidFill>
-              </a:rPr>
-              <a:t>Technical Approach</a:t>
-            </a:r>
-            <a:endParaRPr sz="1800" b="1" dirty="0">
-              <a:solidFill>
-                <a:schemeClr val="dk1"/>
-              </a:solidFill>
-            </a:endParaRPr>
-          </a:p>
-          <a:p>
-            <a:pPr marL="0" lvl="0" indent="0" algn="l" rtl="0">
-              <a:spcBef>
-                <a:spcPts val="0"/>
-              </a:spcBef>
-              <a:spcAft>
-                <a:spcPts val="0"/>
-              </a:spcAft>
-              <a:buNone/>
-            </a:pPr>
-            <a:endParaRPr sz="1800" dirty="0">
-              <a:solidFill>
-                <a:schemeClr val="dk2"/>
-              </a:solidFill>
-            </a:endParaRPr>
+            <a:endParaRPr sz="2200" b="1" dirty="0"/>
           </a:p>
         </p:txBody>
       </p:sp>
@@ -11475,10 +11070,10 @@
       </p:sp>
       <p:pic>
         <p:nvPicPr>
-          <p:cNvPr id="8" name="Picture 7">
+          <p:cNvPr id="5" name="Picture 4">
             <a:extLst>
               <a:ext uri="{FF2B5EF4-FFF2-40B4-BE49-F238E27FC236}">
-                <a16:creationId xmlns:a16="http://schemas.microsoft.com/office/drawing/2014/main" id="{A8576A93-F256-EC44-FDF2-8A4A56103F43}"/>
+                <a16:creationId xmlns:a16="http://schemas.microsoft.com/office/drawing/2014/main" id="{AE677EC3-9EA5-8532-9DE6-5131CB742C62}"/>
               </a:ext>
             </a:extLst>
           </p:cNvPr>
@@ -11495,68 +11090,8 @@
         </p:blipFill>
         <p:spPr>
           <a:xfrm>
-            <a:off x="6620296" y="1017259"/>
-            <a:ext cx="1491787" cy="1653686"/>
-          </a:xfrm>
-          <a:prstGeom prst="rect">
-            <a:avLst/>
-          </a:prstGeom>
-        </p:spPr>
-      </p:pic>
-      <p:pic>
-        <p:nvPicPr>
-          <p:cNvPr id="10" name="Picture 9">
-            <a:extLst>
-              <a:ext uri="{FF2B5EF4-FFF2-40B4-BE49-F238E27FC236}">
-                <a16:creationId xmlns:a16="http://schemas.microsoft.com/office/drawing/2014/main" id="{917F7C63-9E97-C60A-0E29-C683A32ED6B4}"/>
-              </a:ext>
-            </a:extLst>
-          </p:cNvPr>
-          <p:cNvPicPr>
-            <a:picLocks noChangeAspect="1"/>
-          </p:cNvPicPr>
-          <p:nvPr/>
-        </p:nvPicPr>
-        <p:blipFill>
-          <a:blip r:embed="rId4"/>
-          <a:stretch>
-            <a:fillRect/>
-          </a:stretch>
-        </p:blipFill>
-        <p:spPr>
-          <a:xfrm>
-            <a:off x="7421955" y="3102236"/>
-            <a:ext cx="1259231" cy="1416132"/>
-          </a:xfrm>
-          <a:prstGeom prst="rect">
-            <a:avLst/>
-          </a:prstGeom>
-        </p:spPr>
-      </p:pic>
-      <p:pic>
-        <p:nvPicPr>
-          <p:cNvPr id="12" name="Picture 11">
-            <a:extLst>
-              <a:ext uri="{FF2B5EF4-FFF2-40B4-BE49-F238E27FC236}">
-                <a16:creationId xmlns:a16="http://schemas.microsoft.com/office/drawing/2014/main" id="{D5EEA023-DBCC-DA23-03E1-A925B6DA4A70}"/>
-              </a:ext>
-            </a:extLst>
-          </p:cNvPr>
-          <p:cNvPicPr>
-            <a:picLocks noChangeAspect="1"/>
-          </p:cNvPicPr>
-          <p:nvPr/>
-        </p:nvPicPr>
-        <p:blipFill>
-          <a:blip r:embed="rId5"/>
-          <a:stretch>
-            <a:fillRect/>
-          </a:stretch>
-        </p:blipFill>
-        <p:spPr>
-          <a:xfrm>
-            <a:off x="5984855" y="3303169"/>
-            <a:ext cx="1381334" cy="871032"/>
+            <a:off x="3200400" y="914400"/>
+            <a:ext cx="2561860" cy="3611226"/>
           </a:xfrm>
           <a:prstGeom prst="rect">
             <a:avLst/>
@@ -11631,86 +11166,10 @@
               <a:buNone/>
             </a:pPr>
             <a:r>
-              <a:rPr lang="en" sz="2200" b="1"/>
-              <a:t>Expected Challenges and Risks</a:t>
+              <a:rPr lang="en" sz="2200" b="1" dirty="0"/>
+              <a:t>Two Agents</a:t>
             </a:r>
-            <a:endParaRPr sz="2200" b="1"/>
-          </a:p>
-        </p:txBody>
-      </p:sp>
-      <p:sp>
-        <p:nvSpPr>
-          <p:cNvPr id="86" name="Google Shape;86;p4"/>
-          <p:cNvSpPr txBox="1">
-            <a:spLocks noGrp="1"/>
-          </p:cNvSpPr>
-          <p:nvPr>
-            <p:ph type="body" idx="1"/>
-          </p:nvPr>
-        </p:nvSpPr>
-        <p:spPr>
-          <a:xfrm>
-            <a:off x="548640" y="914400"/>
-            <a:ext cx="3291300" cy="486300"/>
-          </a:xfrm>
-          <a:prstGeom prst="rect">
-            <a:avLst/>
-          </a:prstGeom>
-          <a:noFill/>
-          <a:ln>
-            <a:noFill/>
-          </a:ln>
-        </p:spPr>
-        <p:txBody>
-          <a:bodyPr spcFirstLastPara="1" wrap="square" lIns="91425" tIns="91425" rIns="91425" bIns="91425" anchor="t" anchorCtr="0">
-            <a:noAutofit/>
-          </a:bodyPr>
-          <a:lstStyle/>
-          <a:p>
-            <a:pPr marL="0" lvl="0" indent="0" algn="l" rtl="0">
-              <a:lnSpc>
-                <a:spcPct val="200000"/>
-              </a:lnSpc>
-              <a:spcBef>
-                <a:spcPts val="0"/>
-              </a:spcBef>
-              <a:spcAft>
-                <a:spcPts val="0"/>
-              </a:spcAft>
-              <a:buNone/>
-            </a:pPr>
-            <a:r>
-              <a:rPr lang="en" b="1" dirty="0">
-                <a:solidFill>
-                  <a:schemeClr val="dk1"/>
-                </a:solidFill>
-              </a:rPr>
-              <a:t>1. Inertia Tuning:</a:t>
-            </a:r>
-            <a:endParaRPr dirty="0">
-              <a:solidFill>
-                <a:schemeClr val="dk1"/>
-              </a:solidFill>
-            </a:endParaRPr>
-          </a:p>
-          <a:p>
-            <a:pPr marL="0" lvl="0" indent="0" algn="l" rtl="0">
-              <a:lnSpc>
-                <a:spcPct val="200000"/>
-              </a:lnSpc>
-              <a:spcBef>
-                <a:spcPts val="0"/>
-              </a:spcBef>
-              <a:spcAft>
-                <a:spcPts val="0"/>
-              </a:spcAft>
-              <a:buNone/>
-            </a:pPr>
-            <a:endParaRPr sz="1400" dirty="0">
-              <a:solidFill>
-                <a:schemeClr val="dk1"/>
-              </a:solidFill>
-            </a:endParaRPr>
+            <a:endParaRPr sz="2200" b="1" dirty="0"/>
           </a:p>
         </p:txBody>
       </p:sp>
@@ -11761,548 +11220,36 @@
           </a:p>
         </p:txBody>
       </p:sp>
-      <p:sp>
-        <p:nvSpPr>
-          <p:cNvPr id="88" name="Google Shape;88;p4"/>
-          <p:cNvSpPr txBox="1"/>
+      <p:pic>
+        <p:nvPicPr>
+          <p:cNvPr id="3" name="Picture 2">
+            <a:extLst>
+              <a:ext uri="{FF2B5EF4-FFF2-40B4-BE49-F238E27FC236}">
+                <a16:creationId xmlns:a16="http://schemas.microsoft.com/office/drawing/2014/main" id="{06CB09F1-A38A-F12F-C2F9-2FEB5FD861EA}"/>
+              </a:ext>
+            </a:extLst>
+          </p:cNvPr>
+          <p:cNvPicPr>
+            <a:picLocks noChangeAspect="1"/>
+          </p:cNvPicPr>
           <p:nvPr/>
-        </p:nvSpPr>
+        </p:nvPicPr>
+        <p:blipFill>
+          <a:blip r:embed="rId3"/>
+          <a:stretch>
+            <a:fillRect/>
+          </a:stretch>
+        </p:blipFill>
         <p:spPr>
           <a:xfrm>
-            <a:off x="5486400" y="1188720"/>
-            <a:ext cx="3133500" cy="1754400"/>
+            <a:off x="3200400" y="914400"/>
+            <a:ext cx="2448267" cy="3362794"/>
           </a:xfrm>
           <a:prstGeom prst="rect">
             <a:avLst/>
           </a:prstGeom>
-          <a:noFill/>
-          <a:ln>
-            <a:noFill/>
-          </a:ln>
         </p:spPr>
-        <p:txBody>
-          <a:bodyPr spcFirstLastPara="1" wrap="square" lIns="91425" tIns="91425" rIns="91425" bIns="91425" anchor="t" anchorCtr="0">
-            <a:noAutofit/>
-          </a:bodyPr>
-          <a:lstStyle/>
-          <a:p>
-            <a:pPr marL="457200" lvl="0" indent="-317500" algn="l" rtl="0">
-              <a:lnSpc>
-                <a:spcPct val="200000"/>
-              </a:lnSpc>
-              <a:spcBef>
-                <a:spcPts val="0"/>
-              </a:spcBef>
-              <a:spcAft>
-                <a:spcPts val="0"/>
-              </a:spcAft>
-              <a:buClr>
-                <a:schemeClr val="dk1"/>
-              </a:buClr>
-              <a:buSzPts val="1400"/>
-              <a:buChar char="●"/>
-            </a:pPr>
-            <a:r>
-              <a:rPr lang="en" b="1" dirty="0">
-                <a:solidFill>
-                  <a:schemeClr val="dk1"/>
-                </a:solidFill>
-              </a:rPr>
-              <a:t>Too strong </a:t>
-            </a:r>
-            <a:r>
-              <a:rPr lang="en" dirty="0">
-                <a:solidFill>
-                  <a:schemeClr val="dk1"/>
-                </a:solidFill>
-              </a:rPr>
-              <a:t>→ agent sleeps through survival emergencies</a:t>
-            </a:r>
-            <a:endParaRPr dirty="0">
-              <a:solidFill>
-                <a:schemeClr val="dk1"/>
-              </a:solidFill>
-            </a:endParaRPr>
-          </a:p>
-          <a:p>
-            <a:pPr marL="457200" lvl="0" indent="-317500" algn="l" rtl="0">
-              <a:lnSpc>
-                <a:spcPct val="200000"/>
-              </a:lnSpc>
-              <a:spcBef>
-                <a:spcPts val="0"/>
-              </a:spcBef>
-              <a:spcAft>
-                <a:spcPts val="0"/>
-              </a:spcAft>
-              <a:buClr>
-                <a:schemeClr val="dk1"/>
-              </a:buClr>
-              <a:buSzPts val="1400"/>
-              <a:buChar char="●"/>
-            </a:pPr>
-            <a:r>
-              <a:rPr lang="en" b="1" dirty="0">
-                <a:solidFill>
-                  <a:schemeClr val="dk1"/>
-                </a:solidFill>
-              </a:rPr>
-              <a:t>Too weak</a:t>
-            </a:r>
-            <a:r>
-              <a:rPr lang="en" dirty="0">
-                <a:solidFill>
-                  <a:schemeClr val="dk1"/>
-                </a:solidFill>
-              </a:rPr>
-              <a:t> → agent jitters between actions every cycle</a:t>
-            </a:r>
-            <a:endParaRPr dirty="0">
-              <a:solidFill>
-                <a:schemeClr val="dk1"/>
-              </a:solidFill>
-            </a:endParaRPr>
-          </a:p>
-          <a:p>
-            <a:pPr marL="0" lvl="0" indent="0" algn="l" rtl="0">
-              <a:spcBef>
-                <a:spcPts val="0"/>
-              </a:spcBef>
-              <a:spcAft>
-                <a:spcPts val="0"/>
-              </a:spcAft>
-              <a:buNone/>
-            </a:pPr>
-            <a:endParaRPr sz="1800" dirty="0">
-              <a:solidFill>
-                <a:schemeClr val="dk2"/>
-              </a:solidFill>
-            </a:endParaRPr>
-          </a:p>
-        </p:txBody>
-      </p:sp>
-      <p:sp>
-        <p:nvSpPr>
-          <p:cNvPr id="89" name="Google Shape;89;p4"/>
-          <p:cNvSpPr txBox="1"/>
-          <p:nvPr/>
-        </p:nvSpPr>
-        <p:spPr>
-          <a:xfrm>
-            <a:off x="5486400" y="3200400"/>
-            <a:ext cx="3408600" cy="1821900"/>
-          </a:xfrm>
-          <a:prstGeom prst="rect">
-            <a:avLst/>
-          </a:prstGeom>
-          <a:noFill/>
-          <a:ln>
-            <a:noFill/>
-          </a:ln>
-        </p:spPr>
-        <p:txBody>
-          <a:bodyPr spcFirstLastPara="1" wrap="square" lIns="91425" tIns="91425" rIns="91425" bIns="91425" anchor="t" anchorCtr="0">
-            <a:noAutofit/>
-          </a:bodyPr>
-          <a:lstStyle/>
-          <a:p>
-            <a:pPr marL="457200" lvl="0" indent="-317500" algn="l" rtl="0">
-              <a:lnSpc>
-                <a:spcPct val="150000"/>
-              </a:lnSpc>
-              <a:spcBef>
-                <a:spcPts val="0"/>
-              </a:spcBef>
-              <a:spcAft>
-                <a:spcPts val="0"/>
-              </a:spcAft>
-              <a:buClr>
-                <a:schemeClr val="dk1"/>
-              </a:buClr>
-              <a:buSzPts val="1400"/>
-              <a:buChar char="●"/>
-            </a:pPr>
-            <a:r>
-              <a:rPr lang="en" b="1">
-                <a:solidFill>
-                  <a:schemeClr val="dk1"/>
-                </a:solidFill>
-              </a:rPr>
-              <a:t>Stability</a:t>
-            </a:r>
-            <a:r>
-              <a:rPr lang="en">
-                <a:solidFill>
-                  <a:schemeClr val="dk1"/>
-                </a:solidFill>
-              </a:rPr>
-              <a:t> → can be gamed (idle agents score perfectly)</a:t>
-            </a:r>
-            <a:endParaRPr>
-              <a:solidFill>
-                <a:schemeClr val="dk1"/>
-              </a:solidFill>
-            </a:endParaRPr>
-          </a:p>
-          <a:p>
-            <a:pPr marL="457200" lvl="0" indent="-317500" algn="l" rtl="0">
-              <a:lnSpc>
-                <a:spcPct val="150000"/>
-              </a:lnSpc>
-              <a:spcBef>
-                <a:spcPts val="0"/>
-              </a:spcBef>
-              <a:spcAft>
-                <a:spcPts val="0"/>
-              </a:spcAft>
-              <a:buClr>
-                <a:schemeClr val="dk1"/>
-              </a:buClr>
-              <a:buSzPts val="1400"/>
-              <a:buChar char="●"/>
-            </a:pPr>
-            <a:r>
-              <a:rPr lang="en" b="1">
-                <a:solidFill>
-                  <a:schemeClr val="dk1"/>
-                </a:solidFill>
-              </a:rPr>
-              <a:t>Adaptability </a:t>
-            </a:r>
-            <a:r>
-              <a:rPr lang="en">
-                <a:solidFill>
-                  <a:schemeClr val="dk1"/>
-                </a:solidFill>
-              </a:rPr>
-              <a:t>→ depends on how tests are designed (easy or hard scenarios yield no signal)</a:t>
-            </a:r>
-            <a:endParaRPr>
-              <a:solidFill>
-                <a:schemeClr val="dk1"/>
-              </a:solidFill>
-            </a:endParaRPr>
-          </a:p>
-        </p:txBody>
-      </p:sp>
-      <p:sp>
-        <p:nvSpPr>
-          <p:cNvPr id="90" name="Google Shape;90;p4"/>
-          <p:cNvSpPr txBox="1"/>
-          <p:nvPr/>
-        </p:nvSpPr>
-        <p:spPr>
-          <a:xfrm>
-            <a:off x="137160" y="1463040"/>
-            <a:ext cx="3950400" cy="1387800"/>
-          </a:xfrm>
-          <a:prstGeom prst="rect">
-            <a:avLst/>
-          </a:prstGeom>
-          <a:noFill/>
-          <a:ln>
-            <a:noFill/>
-          </a:ln>
-        </p:spPr>
-        <p:txBody>
-          <a:bodyPr spcFirstLastPara="1" wrap="square" lIns="91425" tIns="91425" rIns="91425" bIns="91425" anchor="t" anchorCtr="0">
-            <a:noAutofit/>
-          </a:bodyPr>
-          <a:lstStyle/>
-          <a:p>
-            <a:pPr marL="457200" lvl="0" indent="0" algn="l" rtl="0">
-              <a:lnSpc>
-                <a:spcPct val="200000"/>
-              </a:lnSpc>
-              <a:spcBef>
-                <a:spcPts val="0"/>
-              </a:spcBef>
-              <a:spcAft>
-                <a:spcPts val="0"/>
-              </a:spcAft>
-              <a:buNone/>
-            </a:pPr>
-            <a:r>
-              <a:rPr lang="en" dirty="0">
-                <a:solidFill>
-                  <a:schemeClr val="dk1"/>
-                </a:solidFill>
-              </a:rPr>
-              <a:t>Action inertia is a score bonus on the currently-active action in the utility agent</a:t>
-            </a:r>
-            <a:endParaRPr dirty="0">
-              <a:solidFill>
-                <a:schemeClr val="dk1"/>
-              </a:solidFill>
-            </a:endParaRPr>
-          </a:p>
-          <a:p>
-            <a:pPr marL="457200" lvl="0" indent="0" algn="l" rtl="0">
-              <a:lnSpc>
-                <a:spcPct val="200000"/>
-              </a:lnSpc>
-              <a:spcBef>
-                <a:spcPts val="0"/>
-              </a:spcBef>
-              <a:spcAft>
-                <a:spcPts val="0"/>
-              </a:spcAft>
-              <a:buClr>
-                <a:schemeClr val="dk1"/>
-              </a:buClr>
-              <a:buSzPts val="1100"/>
-              <a:buFont typeface="Arial"/>
-              <a:buNone/>
-            </a:pPr>
-            <a:endParaRPr dirty="0">
-              <a:solidFill>
-                <a:schemeClr val="dk1"/>
-              </a:solidFill>
-            </a:endParaRPr>
-          </a:p>
-          <a:p>
-            <a:pPr marL="0" lvl="0" indent="0" algn="l" rtl="0">
-              <a:spcBef>
-                <a:spcPts val="0"/>
-              </a:spcBef>
-              <a:spcAft>
-                <a:spcPts val="0"/>
-              </a:spcAft>
-              <a:buNone/>
-            </a:pPr>
-            <a:endParaRPr sz="1800" dirty="0">
-              <a:solidFill>
-                <a:schemeClr val="dk2"/>
-              </a:solidFill>
-            </a:endParaRPr>
-          </a:p>
-        </p:txBody>
-      </p:sp>
-      <p:sp>
-        <p:nvSpPr>
-          <p:cNvPr id="91" name="Google Shape;91;p4"/>
-          <p:cNvSpPr txBox="1"/>
-          <p:nvPr/>
-        </p:nvSpPr>
-        <p:spPr>
-          <a:xfrm>
-            <a:off x="137160" y="3200400"/>
-            <a:ext cx="3768900" cy="1204200"/>
-          </a:xfrm>
-          <a:prstGeom prst="rect">
-            <a:avLst/>
-          </a:prstGeom>
-          <a:noFill/>
-          <a:ln>
-            <a:noFill/>
-          </a:ln>
-        </p:spPr>
-        <p:txBody>
-          <a:bodyPr spcFirstLastPara="1" wrap="square" lIns="91425" tIns="91425" rIns="91425" bIns="91425" anchor="t" anchorCtr="0">
-            <a:noAutofit/>
-          </a:bodyPr>
-          <a:lstStyle/>
-          <a:p>
-            <a:pPr marL="457200" lvl="0" indent="0" algn="l" rtl="0">
-              <a:lnSpc>
-                <a:spcPct val="200000"/>
-              </a:lnSpc>
-              <a:spcBef>
-                <a:spcPts val="0"/>
-              </a:spcBef>
-              <a:spcAft>
-                <a:spcPts val="0"/>
-              </a:spcAft>
-              <a:buClr>
-                <a:schemeClr val="dk1"/>
-              </a:buClr>
-              <a:buSzPts val="1100"/>
-              <a:buFont typeface="Arial"/>
-              <a:buNone/>
-            </a:pPr>
-            <a:r>
-              <a:rPr lang="en" dirty="0">
-                <a:solidFill>
-                  <a:schemeClr val="dk1"/>
-                </a:solidFill>
-              </a:rPr>
-              <a:t>Stability and adaptability are numeric proxies for “believable behavior”</a:t>
-            </a:r>
-            <a:endParaRPr sz="1800" dirty="0">
-              <a:solidFill>
-                <a:schemeClr val="dk2"/>
-              </a:solidFill>
-            </a:endParaRPr>
-          </a:p>
-        </p:txBody>
-      </p:sp>
-      <p:sp>
-        <p:nvSpPr>
-          <p:cNvPr id="92" name="Google Shape;92;p4"/>
-          <p:cNvSpPr txBox="1"/>
-          <p:nvPr/>
-        </p:nvSpPr>
-        <p:spPr>
-          <a:xfrm>
-            <a:off x="548640" y="2743200"/>
-            <a:ext cx="3357600" cy="572700"/>
-          </a:xfrm>
-          <a:prstGeom prst="rect">
-            <a:avLst/>
-          </a:prstGeom>
-          <a:noFill/>
-          <a:ln>
-            <a:noFill/>
-          </a:ln>
-        </p:spPr>
-        <p:txBody>
-          <a:bodyPr spcFirstLastPara="1" wrap="square" lIns="91425" tIns="91425" rIns="91425" bIns="91425" anchor="t" anchorCtr="0">
-            <a:noAutofit/>
-          </a:bodyPr>
-          <a:lstStyle/>
-          <a:p>
-            <a:pPr marL="0" lvl="0" indent="0" algn="l" rtl="0">
-              <a:lnSpc>
-                <a:spcPct val="200000"/>
-              </a:lnSpc>
-              <a:spcBef>
-                <a:spcPts val="0"/>
-              </a:spcBef>
-              <a:spcAft>
-                <a:spcPts val="0"/>
-              </a:spcAft>
-              <a:buNone/>
-            </a:pPr>
-            <a:r>
-              <a:rPr lang="en" sz="1800" b="1" dirty="0">
-                <a:solidFill>
-                  <a:schemeClr val="dk1"/>
-                </a:solidFill>
-              </a:rPr>
-              <a:t>2. Metric Validity:</a:t>
-            </a:r>
-            <a:endParaRPr sz="1800" b="1" dirty="0">
-              <a:solidFill>
-                <a:schemeClr val="dk1"/>
-              </a:solidFill>
-            </a:endParaRPr>
-          </a:p>
-          <a:p>
-            <a:pPr marL="0" lvl="0" indent="0" algn="l" rtl="0">
-              <a:spcBef>
-                <a:spcPts val="0"/>
-              </a:spcBef>
-              <a:spcAft>
-                <a:spcPts val="0"/>
-              </a:spcAft>
-              <a:buNone/>
-            </a:pPr>
-            <a:endParaRPr sz="1800" dirty="0">
-              <a:solidFill>
-                <a:schemeClr val="dk2"/>
-              </a:solidFill>
-            </a:endParaRPr>
-          </a:p>
-        </p:txBody>
-      </p:sp>
-      <p:sp>
-        <p:nvSpPr>
-          <p:cNvPr id="93" name="Google Shape;93;p4"/>
-          <p:cNvSpPr/>
-          <p:nvPr/>
-        </p:nvSpPr>
-        <p:spPr>
-          <a:xfrm>
-            <a:off x="3840480" y="3383280"/>
-            <a:ext cx="1561500" cy="630600"/>
-          </a:xfrm>
-          <a:prstGeom prst="rightArrow">
-            <a:avLst>
-              <a:gd name="adj1" fmla="val 50000"/>
-              <a:gd name="adj2" fmla="val 50000"/>
-            </a:avLst>
-          </a:prstGeom>
-          <a:solidFill>
-            <a:schemeClr val="lt2"/>
-          </a:solidFill>
-          <a:ln w="9525" cap="flat" cmpd="sng">
-            <a:solidFill>
-              <a:schemeClr val="dk2"/>
-            </a:solidFill>
-            <a:prstDash val="solid"/>
-            <a:round/>
-            <a:headEnd type="none" w="sm" len="sm"/>
-            <a:tailEnd type="none" w="sm" len="sm"/>
-          </a:ln>
-        </p:spPr>
-        <p:txBody>
-          <a:bodyPr spcFirstLastPara="1" wrap="square" lIns="91425" tIns="91425" rIns="91425" bIns="91425" anchor="ctr" anchorCtr="0">
-            <a:noAutofit/>
-          </a:bodyPr>
-          <a:lstStyle/>
-          <a:p>
-            <a:pPr marL="0" lvl="0" indent="0" algn="ctr" rtl="0">
-              <a:spcBef>
-                <a:spcPts val="0"/>
-              </a:spcBef>
-              <a:spcAft>
-                <a:spcPts val="0"/>
-              </a:spcAft>
-              <a:buNone/>
-            </a:pPr>
-            <a:endParaRPr/>
-          </a:p>
-        </p:txBody>
-      </p:sp>
-      <p:sp>
-        <p:nvSpPr>
-          <p:cNvPr id="94" name="Google Shape;94;p4"/>
-          <p:cNvSpPr/>
-          <p:nvPr/>
-        </p:nvSpPr>
-        <p:spPr>
-          <a:xfrm>
-            <a:off x="3840480" y="1550525"/>
-            <a:ext cx="1561500" cy="630600"/>
-          </a:xfrm>
-          <a:prstGeom prst="rightArrow">
-            <a:avLst>
-              <a:gd name="adj1" fmla="val 50000"/>
-              <a:gd name="adj2" fmla="val 50000"/>
-            </a:avLst>
-          </a:prstGeom>
-          <a:solidFill>
-            <a:schemeClr val="lt2"/>
-          </a:solidFill>
-          <a:ln w="9525" cap="flat" cmpd="sng">
-            <a:solidFill>
-              <a:schemeClr val="dk2"/>
-            </a:solidFill>
-            <a:prstDash val="solid"/>
-            <a:round/>
-            <a:headEnd type="none" w="sm" len="sm"/>
-            <a:tailEnd type="none" w="sm" len="sm"/>
-          </a:ln>
-        </p:spPr>
-        <p:txBody>
-          <a:bodyPr spcFirstLastPara="1" wrap="square" lIns="91425" tIns="91425" rIns="91425" bIns="91425" anchor="ctr" anchorCtr="0">
-            <a:noAutofit/>
-          </a:bodyPr>
-          <a:lstStyle/>
-          <a:p>
-            <a:pPr marL="0" lvl="0" indent="0" algn="ctr" rtl="0">
-              <a:spcBef>
-                <a:spcPts val="0"/>
-              </a:spcBef>
-              <a:spcAft>
-                <a:spcPts val="0"/>
-              </a:spcAft>
-              <a:buNone/>
-            </a:pPr>
-            <a:endParaRPr/>
-          </a:p>
-        </p:txBody>
-      </p:sp>
+      </p:pic>
     </p:spTree>
   </p:cSld>
   <p:clrMapOvr>
@@ -12372,137 +11319,9 @@
             </a:pPr>
             <a:r>
               <a:rPr lang="en" sz="2200" b="1" dirty="0"/>
-              <a:t>Review of Existing Work in this Area</a:t>
+              <a:t>Response Curves</a:t>
             </a:r>
             <a:endParaRPr sz="2200" b="1" dirty="0"/>
-          </a:p>
-        </p:txBody>
-      </p:sp>
-      <p:sp>
-        <p:nvSpPr>
-          <p:cNvPr id="100" name="Google Shape;100;p5"/>
-          <p:cNvSpPr txBox="1">
-            <a:spLocks noGrp="1"/>
-          </p:cNvSpPr>
-          <p:nvPr>
-            <p:ph type="body" idx="1"/>
-          </p:nvPr>
-        </p:nvSpPr>
-        <p:spPr>
-          <a:xfrm>
-            <a:off x="548640" y="914400"/>
-            <a:ext cx="6756600" cy="699000"/>
-          </a:xfrm>
-          <a:prstGeom prst="rect">
-            <a:avLst/>
-          </a:prstGeom>
-          <a:noFill/>
-          <a:ln>
-            <a:noFill/>
-          </a:ln>
-        </p:spPr>
-        <p:txBody>
-          <a:bodyPr spcFirstLastPara="1" wrap="square" lIns="91425" tIns="91425" rIns="91425" bIns="91425" anchor="t" anchorCtr="0">
-            <a:noAutofit/>
-          </a:bodyPr>
-          <a:lstStyle/>
-          <a:p>
-            <a:pPr marL="0" lvl="0" indent="0" algn="l" rtl="0">
-              <a:spcBef>
-                <a:spcPts val="0"/>
-              </a:spcBef>
-              <a:spcAft>
-                <a:spcPts val="0"/>
-              </a:spcAft>
-              <a:buSzPts val="7200"/>
-              <a:buNone/>
-            </a:pPr>
-            <a:r>
-              <a:rPr lang="en" sz="1400" b="1" dirty="0">
-                <a:solidFill>
-                  <a:schemeClr val="dk1"/>
-                </a:solidFill>
-              </a:rPr>
-              <a:t>Emergent NPC decision-making:</a:t>
-            </a:r>
-            <a:endParaRPr sz="1400" b="1" dirty="0">
-              <a:solidFill>
-                <a:schemeClr val="dk1"/>
-              </a:solidFill>
-            </a:endParaRPr>
-          </a:p>
-          <a:p>
-            <a:pPr marL="0" lvl="0" indent="0" algn="l" rtl="0">
-              <a:spcBef>
-                <a:spcPts val="0"/>
-              </a:spcBef>
-              <a:spcAft>
-                <a:spcPts val="0"/>
-              </a:spcAft>
-              <a:buNone/>
-            </a:pPr>
-            <a:r>
-              <a:rPr lang="en" sz="1400" i="1" dirty="0">
-                <a:solidFill>
-                  <a:schemeClr val="dk1"/>
-                </a:solidFill>
-              </a:rPr>
-              <a:t>aims for stable, adaptive behavior without a scripted response for every situation</a:t>
-            </a:r>
-            <a:endParaRPr sz="1400" i="1" dirty="0">
-              <a:solidFill>
-                <a:schemeClr val="dk1"/>
-              </a:solidFill>
-            </a:endParaRPr>
-          </a:p>
-          <a:p>
-            <a:pPr marL="0" lvl="0" indent="0" algn="l" rtl="0">
-              <a:spcBef>
-                <a:spcPts val="0"/>
-              </a:spcBef>
-              <a:spcAft>
-                <a:spcPts val="0"/>
-              </a:spcAft>
-              <a:buNone/>
-            </a:pPr>
-            <a:endParaRPr sz="1400" i="1" dirty="0">
-              <a:solidFill>
-                <a:schemeClr val="dk1"/>
-              </a:solidFill>
-            </a:endParaRPr>
-          </a:p>
-          <a:p>
-            <a:pPr marL="0" lvl="0" indent="0" algn="l" rtl="0">
-              <a:spcBef>
-                <a:spcPts val="0"/>
-              </a:spcBef>
-              <a:spcAft>
-                <a:spcPts val="0"/>
-              </a:spcAft>
-              <a:buNone/>
-            </a:pPr>
-            <a:endParaRPr sz="1400" i="1" dirty="0">
-              <a:solidFill>
-                <a:schemeClr val="dk1"/>
-              </a:solidFill>
-            </a:endParaRPr>
-          </a:p>
-          <a:p>
-            <a:pPr marL="0" lvl="0" indent="457200" algn="l" rtl="0">
-              <a:spcBef>
-                <a:spcPts val="0"/>
-              </a:spcBef>
-              <a:spcAft>
-                <a:spcPts val="0"/>
-              </a:spcAft>
-              <a:buSzPts val="7200"/>
-              <a:buNone/>
-            </a:pPr>
-            <a:endParaRPr sz="1400" dirty="0">
-              <a:solidFill>
-                <a:schemeClr val="dk1"/>
-              </a:solidFill>
-            </a:endParaRPr>
           </a:p>
         </p:txBody>
       </p:sp>
@@ -12553,304 +11372,6 @@
           </a:p>
         </p:txBody>
       </p:sp>
-      <p:graphicFrame>
-        <p:nvGraphicFramePr>
-          <p:cNvPr id="102" name="Google Shape;102;p5"/>
-          <p:cNvGraphicFramePr/>
-          <p:nvPr>
-            <p:extLst>
-              <p:ext uri="{D42A27DB-BD31-4B8C-83A1-F6EECF244321}">
-                <p14:modId xmlns:p14="http://schemas.microsoft.com/office/powerpoint/2010/main" val="4008651297"/>
-              </p:ext>
-            </p:extLst>
-          </p:nvPr>
-        </p:nvGraphicFramePr>
-        <p:xfrm>
-          <a:off x="548640" y="1645920"/>
-          <a:ext cx="8176000" cy="2701000"/>
-        </p:xfrm>
-        <a:graphic>
-          <a:graphicData uri="http://schemas.openxmlformats.org/drawingml/2006/table">
-            <a:tbl>
-              <a:tblPr>
-                <a:noFill/>
-                <a:tableStyleId>{629DBEC2-58FE-42DA-915E-554960D095A8}</a:tableStyleId>
-              </a:tblPr>
-              <a:tblGrid>
-                <a:gridCol w="4088000">
-                  <a:extLst>
-                    <a:ext uri="{9D8B030D-6E8A-4147-A177-3AD203B41FA5}">
-                      <a16:colId xmlns:a16="http://schemas.microsoft.com/office/drawing/2014/main" val="20000"/>
-                    </a:ext>
-                  </a:extLst>
-                </a:gridCol>
-                <a:gridCol w="4088000">
-                  <a:extLst>
-                    <a:ext uri="{9D8B030D-6E8A-4147-A177-3AD203B41FA5}">
-                      <a16:colId xmlns:a16="http://schemas.microsoft.com/office/drawing/2014/main" val="20001"/>
-                    </a:ext>
-                  </a:extLst>
-                </a:gridCol>
-              </a:tblGrid>
-              <a:tr h="496150">
-                <a:tc gridSpan="2">
-                  <a:txBody>
-                    <a:bodyPr/>
-                    <a:lstStyle/>
-                    <a:p>
-                      <a:pPr marL="0" lvl="0" indent="0" algn="ctr" rtl="0">
-                        <a:spcBef>
-                          <a:spcPts val="0"/>
-                        </a:spcBef>
-                        <a:spcAft>
-                          <a:spcPts val="0"/>
-                        </a:spcAft>
-                        <a:buNone/>
-                      </a:pPr>
-                      <a:r>
-                        <a:rPr lang="en-US" b="1" dirty="0"/>
-                        <a:t>Two Main Directions</a:t>
-                      </a:r>
-                      <a:endParaRPr b="1" dirty="0"/>
-                    </a:p>
-                  </a:txBody>
-                  <a:tcPr marL="91425" marR="91425" marT="91425" marB="91425">
-                    <a:solidFill>
-                      <a:schemeClr val="lt2"/>
-                    </a:solidFill>
-                  </a:tcPr>
-                </a:tc>
-                <a:tc hMerge="1">
-                  <a:txBody>
-                    <a:bodyPr/>
-                    <a:lstStyle/>
-                    <a:p>
-                      <a:endParaRPr lang="en-US"/>
-                    </a:p>
-                  </a:txBody>
-                  <a:tcPr/>
-                </a:tc>
-                <a:extLst>
-                  <a:ext uri="{0D108BD9-81ED-4DB2-BD59-A6C34878D82A}">
-                    <a16:rowId xmlns:a16="http://schemas.microsoft.com/office/drawing/2014/main" val="10000"/>
-                  </a:ext>
-                </a:extLst>
-              </a:tr>
-              <a:tr h="451500">
-                <a:tc>
-                  <a:txBody>
-                    <a:bodyPr/>
-                    <a:lstStyle/>
-                    <a:p>
-                      <a:pPr marL="0" lvl="0" indent="0" algn="l" rtl="0">
-                        <a:spcBef>
-                          <a:spcPts val="0"/>
-                        </a:spcBef>
-                        <a:spcAft>
-                          <a:spcPts val="0"/>
-                        </a:spcAft>
-                        <a:buNone/>
-                      </a:pPr>
-                      <a:r>
-                        <a:rPr lang="en" dirty="0"/>
-                        <a:t>Lightweight / Classical (Utility AI)</a:t>
-                      </a:r>
-                      <a:endParaRPr dirty="0"/>
-                    </a:p>
-                  </a:txBody>
-                  <a:tcPr marL="91425" marR="91425" marT="91425" marB="91425"/>
-                </a:tc>
-                <a:tc>
-                  <a:txBody>
-                    <a:bodyPr/>
-                    <a:lstStyle/>
-                    <a:p>
-                      <a:pPr marL="0" lvl="0" indent="0" algn="l" rtl="0">
-                        <a:spcBef>
-                          <a:spcPts val="0"/>
-                        </a:spcBef>
-                        <a:spcAft>
-                          <a:spcPts val="0"/>
-                        </a:spcAft>
-                        <a:buNone/>
-                      </a:pPr>
-                      <a:r>
-                        <a:rPr lang="en"/>
-                        <a:t>Heavy / Generative (LLM-driven agents)</a:t>
-                      </a:r>
-                      <a:endParaRPr/>
-                    </a:p>
-                  </a:txBody>
-                  <a:tcPr marL="91425" marR="91425" marT="91425" marB="91425"/>
-                </a:tc>
-                <a:extLst>
-                  <a:ext uri="{0D108BD9-81ED-4DB2-BD59-A6C34878D82A}">
-                    <a16:rowId xmlns:a16="http://schemas.microsoft.com/office/drawing/2014/main" val="10001"/>
-                  </a:ext>
-                </a:extLst>
-              </a:tr>
-              <a:tr h="1753350">
-                <a:tc>
-                  <a:txBody>
-                    <a:bodyPr/>
-                    <a:lstStyle/>
-                    <a:p>
-                      <a:pPr marL="457200" lvl="0" indent="-317500" algn="l" rtl="0">
-                        <a:lnSpc>
-                          <a:spcPct val="150000"/>
-                        </a:lnSpc>
-                        <a:spcBef>
-                          <a:spcPts val="0"/>
-                        </a:spcBef>
-                        <a:spcAft>
-                          <a:spcPts val="0"/>
-                        </a:spcAft>
-                        <a:buClr>
-                          <a:schemeClr val="dk1"/>
-                        </a:buClr>
-                        <a:buSzPts val="1400"/>
-                        <a:buChar char="●"/>
-                      </a:pPr>
-                      <a:r>
-                        <a:rPr lang="en" dirty="0">
-                          <a:solidFill>
-                            <a:schemeClr val="dk1"/>
-                          </a:solidFill>
-                        </a:rPr>
-                        <a:t>Agents score each action mathematically, pick the highest</a:t>
-                      </a:r>
-                      <a:endParaRPr dirty="0">
-                        <a:solidFill>
-                          <a:schemeClr val="dk1"/>
-                        </a:solidFill>
-                      </a:endParaRPr>
-                    </a:p>
-                    <a:p>
-                      <a:pPr marL="457200" lvl="0" indent="-317500" algn="l" rtl="0">
-                        <a:lnSpc>
-                          <a:spcPct val="150000"/>
-                        </a:lnSpc>
-                        <a:spcBef>
-                          <a:spcPts val="0"/>
-                        </a:spcBef>
-                        <a:spcAft>
-                          <a:spcPts val="0"/>
-                        </a:spcAft>
-                        <a:buClr>
-                          <a:schemeClr val="dk1"/>
-                        </a:buClr>
-                        <a:buSzPts val="1400"/>
-                        <a:buChar char="●"/>
-                      </a:pPr>
-                      <a:r>
-                        <a:rPr lang="en" dirty="0">
-                          <a:solidFill>
-                            <a:schemeClr val="dk1"/>
-                          </a:solidFill>
-                        </a:rPr>
-                        <a:t>Textbook defines response curves and action inertia, but </a:t>
-                      </a:r>
-                      <a:r>
-                        <a:rPr lang="en-US" sz="1400" b="0" i="0" u="none" strike="noStrike" cap="none" dirty="0">
-                          <a:solidFill>
-                            <a:srgbClr val="000000"/>
-                          </a:solidFill>
-                          <a:effectLst/>
-                          <a:latin typeface="Arial"/>
-                          <a:ea typeface="Arial"/>
-                          <a:cs typeface="Arial"/>
-                          <a:sym typeface="Arial"/>
-                        </a:rPr>
-                        <a:t>but does not measure how much each one contributes</a:t>
-                      </a:r>
-                      <a:endParaRPr dirty="0">
-                        <a:solidFill>
-                          <a:schemeClr val="dk1"/>
-                        </a:solidFill>
-                      </a:endParaRPr>
-                    </a:p>
-                  </a:txBody>
-                  <a:tcPr marL="91425" marR="91425" marT="91425" marB="91425"/>
-                </a:tc>
-                <a:tc>
-                  <a:txBody>
-                    <a:bodyPr/>
-                    <a:lstStyle/>
-                    <a:p>
-                      <a:pPr marL="457200" lvl="0" indent="-317500" algn="l" rtl="0">
-                        <a:lnSpc>
-                          <a:spcPct val="150000"/>
-                        </a:lnSpc>
-                        <a:spcBef>
-                          <a:spcPts val="0"/>
-                        </a:spcBef>
-                        <a:spcAft>
-                          <a:spcPts val="0"/>
-                        </a:spcAft>
-                        <a:buClr>
-                          <a:schemeClr val="dk1"/>
-                        </a:buClr>
-                        <a:buSzPts val="1400"/>
-                        <a:buChar char="●"/>
-                      </a:pPr>
-                      <a:r>
-                        <a:rPr lang="en" dirty="0">
-                          <a:solidFill>
-                            <a:schemeClr val="dk1"/>
-                          </a:solidFill>
-                        </a:rPr>
-                        <a:t>LLM agents plan, remember, and socialize believably (25-NPC sandbox study)</a:t>
-                      </a:r>
-                    </a:p>
-                    <a:p>
-                      <a:pPr marL="457200" lvl="0" indent="-317500" algn="l" rtl="0">
-                        <a:lnSpc>
-                          <a:spcPct val="150000"/>
-                        </a:lnSpc>
-                        <a:spcBef>
-                          <a:spcPts val="0"/>
-                        </a:spcBef>
-                        <a:spcAft>
-                          <a:spcPts val="0"/>
-                        </a:spcAft>
-                        <a:buClr>
-                          <a:schemeClr val="dk1"/>
-                        </a:buClr>
-                        <a:buSzPts val="1400"/>
-                        <a:buChar char="●"/>
-                      </a:pPr>
-                      <a:r>
-                        <a:rPr lang="en-US" sz="1400" b="0" i="0" u="none" strike="noStrike" cap="none" dirty="0">
-                          <a:solidFill>
-                            <a:srgbClr val="000000"/>
-                          </a:solidFill>
-                          <a:effectLst/>
-                          <a:latin typeface="Arial"/>
-                          <a:ea typeface="Arial"/>
-                          <a:cs typeface="Arial"/>
-                          <a:sym typeface="Arial"/>
-                        </a:rPr>
-                        <a:t>Decisions emerge from the model as a whole, so individual mechanisms cannot be isolated</a:t>
-                      </a:r>
-                      <a:endParaRPr dirty="0">
-                        <a:solidFill>
-                          <a:schemeClr val="dk1"/>
-                        </a:solidFill>
-                      </a:endParaRPr>
-                    </a:p>
-                  </a:txBody>
-                  <a:tcPr marL="91425" marR="91425" marT="91425" marB="91425"/>
-                </a:tc>
-                <a:extLst>
-                  <a:ext uri="{0D108BD9-81ED-4DB2-BD59-A6C34878D82A}">
-                    <a16:rowId xmlns:a16="http://schemas.microsoft.com/office/drawing/2014/main" val="10002"/>
-                  </a:ext>
-                </a:extLst>
-              </a:tr>
-            </a:tbl>
-          </a:graphicData>
-        </a:graphic>
-      </p:graphicFrame>
       <p:sp>
         <p:nvSpPr>
           <p:cNvPr id="103" name="Google Shape;103;p5"/>
@@ -12859,7 +11380,7 @@
         </p:nvSpPr>
         <p:spPr>
           <a:xfrm>
-            <a:off x="548640" y="4389120"/>
+            <a:off x="7315200" y="4389120"/>
             <a:ext cx="1517100" cy="393600"/>
           </a:xfrm>
           <a:prstGeom prst="rect">
@@ -12894,56 +11415,6 @@
               <a:t>(Mark, 2009)</a:t>
             </a:r>
             <a:endParaRPr sz="1100" dirty="0">
-              <a:solidFill>
-                <a:schemeClr val="dk2"/>
-              </a:solidFill>
-            </a:endParaRPr>
-          </a:p>
-        </p:txBody>
-      </p:sp>
-      <p:sp>
-        <p:nvSpPr>
-          <p:cNvPr id="104" name="Google Shape;104;p5"/>
-          <p:cNvSpPr txBox="1"/>
-          <p:nvPr/>
-        </p:nvSpPr>
-        <p:spPr>
-          <a:xfrm>
-            <a:off x="7315200" y="4389120"/>
-            <a:ext cx="1380000" cy="393600"/>
-          </a:xfrm>
-          <a:prstGeom prst="rect">
-            <a:avLst/>
-          </a:prstGeom>
-          <a:noFill/>
-          <a:ln>
-            <a:noFill/>
-          </a:ln>
-        </p:spPr>
-        <p:txBody>
-          <a:bodyPr spcFirstLastPara="1" wrap="square" lIns="91425" tIns="91425" rIns="91425" bIns="91425" anchor="t" anchorCtr="0">
-            <a:noAutofit/>
-          </a:bodyPr>
-          <a:lstStyle/>
-          <a:p>
-            <a:pPr marL="0" lvl="0" indent="0" algn="l" rtl="0">
-              <a:spcBef>
-                <a:spcPts val="0"/>
-              </a:spcBef>
-              <a:spcAft>
-                <a:spcPts val="0"/>
-              </a:spcAft>
-              <a:buNone/>
-            </a:pPr>
-            <a:r>
-              <a:rPr lang="en" sz="1100">
-                <a:solidFill>
-                  <a:schemeClr val="dk2"/>
-                </a:solidFill>
-              </a:rPr>
-              <a:t>(Park et al., 2023)</a:t>
-            </a:r>
-            <a:endParaRPr sz="1100">
               <a:solidFill>
                 <a:schemeClr val="dk2"/>
               </a:solidFill>

</xml_diff>